<commit_message>
Sổ tay: thêm logo bó lúa Thạnh Hương, tên công ty & người thực hiện (Phan Tấn Phương)
- Thiết kế logo huy hiệu bó lúa (SVG) cho cả PDF và slide
- Bìa: CÔNG TY TNHH TM DV XNK THÀNH HƯNG + Nhà máy Xay xát Gạo Thạnh Hương
- Ghi "Người thực hiện: Phan Tấn Phương" ở bìa và trang cuối

https://claude.ai/code/session_01UPYJGEeCKrEvHEii9xoqN5
</commit_message>
<xml_diff>
--- a/automation-thanh-huong/huong-dan/SoTay_MiniApp_ThanhHuong.pptx
+++ b/automation-thanh-huong/huong-dan/SoTay_MiniApp_ThanhHuong.pptx
@@ -1894,45 +1894,33 @@
           <a:ln/>
         </p:spPr>
       </p:sp>
-      <p:sp>
-        <p:nvSpPr>
-          <p:cNvPr id="4" name="Text 2"/>
-          <p:cNvSpPr/>
-          <p:nvPr/>
-        </p:nvSpPr>
-        <p:spPr>
-          <a:xfrm>
-            <a:off x="640080" y="640080"/>
-            <a:ext cx="1280160" cy="1097280"/>
-          </a:xfrm>
-          <a:prstGeom prst="rect">
-            <a:avLst/>
-          </a:prstGeom>
-          <a:noFill/>
-          <a:ln/>
-        </p:spPr>
-        <p:txBody>
-          <a:bodyPr wrap="square" rtlCol="0" anchor="ctr"/>
-          <a:lstStyle/>
-          <a:p>
-            <a:pPr algn="l" indent="0" marL="0">
-              <a:buNone/>
-            </a:pPr>
-            <a:r>
-              <a:rPr lang="en-US" sz="5400" dirty="0">
-                <a:solidFill>
-                  <a:srgbClr val="000000"/>
-                </a:solidFill>
-              </a:rPr>
-              <a:t>🌾</a:t>
-            </a:r>
-            <a:endParaRPr lang="en-US" sz="5400" dirty="0"/>
-          </a:p>
-        </p:txBody>
-      </p:sp>
-      <p:sp>
-        <p:nvSpPr>
-          <p:cNvPr id="5" name="Text 3"/>
+      <p:pic>
+        <p:nvPicPr>
+          <p:cNvPr id="4" name="Image 0" descr="/tmp/claude-0/-home-user-n8n/e6b51ae7-6c99-5683-8277-7db523f0061c/scratchpad/huongdan/logo.png">    </p:cNvPr>
+          <p:cNvPicPr>
+            <a:picLocks noChangeAspect="1"/>
+          </p:cNvPicPr>
+          <p:nvPr/>
+        </p:nvPicPr>
+        <p:blipFill>
+          <a:blip r:embed="rId1"/>
+          <a:stretch>
+            <a:fillRect/>
+          </a:stretch>
+        </p:blipFill>
+        <p:spPr>
+          <a:xfrm>
+            <a:off x="640080" y="457200"/>
+            <a:ext cx="1463040" cy="1463040"/>
+          </a:xfrm>
+          <a:prstGeom prst="rect">
+            <a:avLst/>
+          </a:prstGeom>
+        </p:spPr>
+      </p:pic>
+      <p:sp>
+        <p:nvSpPr>
+          <p:cNvPr id="5" name="Text 2"/>
           <p:cNvSpPr/>
           <p:nvPr/>
         </p:nvSpPr>
@@ -1971,7 +1959,7 @@
       </p:sp>
       <p:sp>
         <p:nvSpPr>
-          <p:cNvPr id="6" name="Text 4"/>
+          <p:cNvPr id="6" name="Text 3"/>
           <p:cNvSpPr/>
           <p:nvPr/>
         </p:nvSpPr>
@@ -2010,7 +1998,7 @@
       </p:sp>
       <p:sp>
         <p:nvSpPr>
-          <p:cNvPr id="7" name="Text 5"/>
+          <p:cNvPr id="7" name="Text 4"/>
           <p:cNvSpPr/>
           <p:nvPr/>
         </p:nvSpPr>
@@ -2072,7 +2060,7 @@
       </p:sp>
       <p:sp>
         <p:nvSpPr>
-          <p:cNvPr id="8" name="Shape 6"/>
+          <p:cNvPr id="8" name="Shape 5"/>
           <p:cNvSpPr/>
           <p:nvPr/>
         </p:nvSpPr>
@@ -2094,7 +2082,7 @@
       </p:sp>
       <p:sp>
         <p:nvSpPr>
-          <p:cNvPr id="9" name="Text 7"/>
+          <p:cNvPr id="9" name="Text 6"/>
           <p:cNvSpPr/>
           <p:nvPr/>
         </p:nvSpPr>
@@ -2133,40 +2121,132 @@
       </p:sp>
       <p:sp>
         <p:nvSpPr>
-          <p:cNvPr id="10" name="Text 8"/>
-          <p:cNvSpPr/>
-          <p:nvPr/>
-        </p:nvSpPr>
-        <p:spPr>
-          <a:xfrm>
-            <a:off x="685800" y="6035040"/>
-            <a:ext cx="8229600" cy="320040"/>
-          </a:xfrm>
-          <a:prstGeom prst="rect">
-            <a:avLst/>
-          </a:prstGeom>
-          <a:noFill/>
-          <a:ln/>
-        </p:spPr>
-        <p:txBody>
-          <a:bodyPr wrap="square" rtlCol="0" anchor="ctr"/>
-          <a:lstStyle/>
-          <a:p>
-            <a:pPr indent="0" marL="0">
-              <a:buNone/>
-            </a:pPr>
-            <a:r>
-              <a:rPr lang="en-US" sz="1200" dirty="0">
-                <a:solidFill>
-                  <a:srgbClr val="AFC3B4"/>
+          <p:cNvPr id="10" name="Text 7"/>
+          <p:cNvSpPr/>
+          <p:nvPr/>
+        </p:nvSpPr>
+        <p:spPr>
+          <a:xfrm>
+            <a:off x="685800" y="5760720"/>
+            <a:ext cx="10058400" cy="320040"/>
+          </a:xfrm>
+          <a:prstGeom prst="rect">
+            <a:avLst/>
+          </a:prstGeom>
+          <a:noFill/>
+          <a:ln/>
+        </p:spPr>
+        <p:txBody>
+          <a:bodyPr wrap="square" rtlCol="0" anchor="ctr"/>
+          <a:lstStyle/>
+          <a:p>
+            <a:pPr indent="0" marL="0">
+              <a:buNone/>
+            </a:pPr>
+            <a:r>
+              <a:rPr lang="en-US" sz="1300" b="1" spc="100" kern="0" dirty="0">
+                <a:solidFill>
+                  <a:srgbClr val="E0A83B"/>
                 </a:solidFill>
                 <a:latin typeface="Calibri" pitchFamily="34" charset="0"/>
                 <a:ea typeface="Calibri" pitchFamily="34" charset="-122"/>
                 <a:cs typeface="Calibri" pitchFamily="34" charset="-120"/>
               </a:rPr>
+              <a:t>CÔNG TY TNHH TM DV XNK THÀNH HƯNG</a:t>
+            </a:r>
+            <a:endParaRPr lang="en-US" sz="1300" dirty="0"/>
+          </a:p>
+        </p:txBody>
+      </p:sp>
+      <p:sp>
+        <p:nvSpPr>
+          <p:cNvPr id="11" name="Text 8"/>
+          <p:cNvSpPr/>
+          <p:nvPr/>
+        </p:nvSpPr>
+        <p:spPr>
+          <a:xfrm>
+            <a:off x="685800" y="6108192"/>
+            <a:ext cx="8229600" cy="274320"/>
+          </a:xfrm>
+          <a:prstGeom prst="rect">
+            <a:avLst/>
+          </a:prstGeom>
+          <a:noFill/>
+          <a:ln/>
+        </p:spPr>
+        <p:txBody>
+          <a:bodyPr wrap="square" rtlCol="0" anchor="ctr"/>
+          <a:lstStyle/>
+          <a:p>
+            <a:pPr indent="0" marL="0">
+              <a:buNone/>
+            </a:pPr>
+            <a:r>
+              <a:rPr lang="en-US" sz="1150" dirty="0">
+                <a:solidFill>
+                  <a:srgbClr val="AFC3B4"/>
+                </a:solidFill>
+                <a:latin typeface="Calibri" pitchFamily="34" charset="0"/>
+                <a:ea typeface="Calibri" pitchFamily="34" charset="-122"/>
+                <a:cs typeface="Calibri" pitchFamily="34" charset="-120"/>
+              </a:rPr>
               <a:t>Nhà máy Xay xát Gạo Thạnh Hương</a:t>
             </a:r>
-            <a:endParaRPr lang="en-US" sz="1200" dirty="0"/>
+            <a:endParaRPr lang="en-US" sz="1150" dirty="0"/>
+          </a:p>
+        </p:txBody>
+      </p:sp>
+      <p:sp>
+        <p:nvSpPr>
+          <p:cNvPr id="12" name="Text 9"/>
+          <p:cNvSpPr/>
+          <p:nvPr/>
+        </p:nvSpPr>
+        <p:spPr>
+          <a:xfrm>
+            <a:off x="685800" y="6382512"/>
+            <a:ext cx="8229600" cy="274320"/>
+          </a:xfrm>
+          <a:prstGeom prst="rect">
+            <a:avLst/>
+          </a:prstGeom>
+          <a:noFill/>
+          <a:ln/>
+        </p:spPr>
+        <p:txBody>
+          <a:bodyPr wrap="square" rtlCol="0" anchor="ctr"/>
+          <a:lstStyle/>
+          <a:p>
+            <a:pPr indent="0" marL="0">
+              <a:buNone/>
+            </a:pPr>
+            <a:r>
+              <a:rPr lang="en-US" sz="1150" dirty="0">
+                <a:solidFill>
+                  <a:srgbClr val="AFC3B4"/>
+                </a:solidFill>
+                <a:latin typeface="Calibri" pitchFamily="34" charset="0"/>
+                <a:ea typeface="Calibri" pitchFamily="34" charset="-122"/>
+                <a:cs typeface="Calibri" pitchFamily="34" charset="-120"/>
+              </a:rPr>
+              <a:t>Người thực hiện: </a:t>
+            </a:r>
+            <a:pPr indent="0" marL="0">
+              <a:buNone/>
+            </a:pPr>
+            <a:r>
+              <a:rPr lang="en-US" sz="1150" b="1" dirty="0">
+                <a:solidFill>
+                  <a:srgbClr val="FFFFFF"/>
+                </a:solidFill>
+                <a:latin typeface="Calibri" pitchFamily="34" charset="0"/>
+                <a:ea typeface="Calibri" pitchFamily="34" charset="-122"/>
+                <a:cs typeface="Calibri" pitchFamily="34" charset="-120"/>
+              </a:rPr>
+              <a:t>Phan Tấn Phương</a:t>
+            </a:r>
+            <a:endParaRPr lang="en-US" sz="1150" dirty="0"/>
           </a:p>
         </p:txBody>
       </p:sp>
@@ -4379,7 +4459,60 @@
       </p:sp>
       <p:sp>
         <p:nvSpPr>
-          <p:cNvPr id="18" name="Shape 16"/>
+          <p:cNvPr id="18" name="Text 16"/>
+          <p:cNvSpPr/>
+          <p:nvPr/>
+        </p:nvSpPr>
+        <p:spPr>
+          <a:xfrm>
+            <a:off x="640080" y="5230368"/>
+            <a:ext cx="10908792" cy="320040"/>
+          </a:xfrm>
+          <a:prstGeom prst="rect">
+            <a:avLst/>
+          </a:prstGeom>
+          <a:noFill/>
+          <a:ln/>
+        </p:spPr>
+        <p:txBody>
+          <a:bodyPr wrap="square" rtlCol="0" anchor="ctr"/>
+          <a:lstStyle/>
+          <a:p>
+            <a:pPr algn="r" indent="0" marL="0">
+              <a:buNone/>
+            </a:pPr>
+            <a:r>
+              <a:rPr lang="en-US" sz="1300" dirty="0">
+                <a:solidFill>
+                  <a:srgbClr val="AFC3B4"/>
+                </a:solidFill>
+                <a:latin typeface="Calibri" pitchFamily="34" charset="0"/>
+                <a:ea typeface="Calibri" pitchFamily="34" charset="-122"/>
+                <a:cs typeface="Calibri" pitchFamily="34" charset="-120"/>
+              </a:rPr>
+              <a:t>Biên soạn &amp; triển khai:  </a:t>
+            </a:r>
+            <a:pPr algn="r" indent="0" marL="0">
+              <a:buNone/>
+            </a:pPr>
+            <a:r>
+              <a:rPr lang="en-US" sz="1300" b="1" dirty="0">
+                <a:solidFill>
+                  <a:srgbClr val="E0A83B"/>
+                </a:solidFill>
+                <a:latin typeface="Calibri" pitchFamily="34" charset="0"/>
+                <a:ea typeface="Calibri" pitchFamily="34" charset="-122"/>
+                <a:cs typeface="Calibri" pitchFamily="34" charset="-120"/>
+              </a:rPr>
+              <a:t>Phan Tấn Phương</a:t>
+            </a:r>
+            <a:endParaRPr lang="en-US" sz="1300" dirty="0"/>
+          </a:p>
+        </p:txBody>
+      </p:sp>
+      <p:sp>
+        <p:nvSpPr>
+          <p:cNvPr id="19" name="Shape 17"/>
           <p:cNvSpPr/>
           <p:nvPr/>
         </p:nvSpPr>
@@ -4408,7 +4541,7 @@
       </p:sp>
       <p:sp>
         <p:nvSpPr>
-          <p:cNvPr id="19" name="Text 17"/>
+          <p:cNvPr id="20" name="Text 18"/>
           <p:cNvSpPr/>
           <p:nvPr/>
         </p:nvSpPr>

</xml_diff>

<commit_message>
Sổ tay: cập nhật toàn bộ theo logo công ty mới (Thành Hưng)
- Dùng logo thật (TH + nhà máy + đồng lúa) trên bìa PDF và slide
- Đổi tông màu khớp thương hiệu: xanh #15451F, vàng #D3AF2D, nền kem #F4EDDD
- Thay logo bó lúa tự vẽ trước đó

https://claude.ai/code/session_01UPYJGEeCKrEvHEii9xoqN5
</commit_message>
<xml_diff>
--- a/automation-thanh-huong/huong-dan/SoTay_MiniApp_ThanhHuong.pptx
+++ b/automation-thanh-huong/huong-dan/SoTay_MiniApp_ThanhHuong.pptx
@@ -1836,7 +1836,7 @@
     <p:bg>
       <p:bgPr>
         <a:solidFill>
-          <a:srgbClr val="1E4D2B"/>
+          <a:srgbClr val="15451F"/>
         </a:solidFill>
       </p:bgPr>
     </p:bg>
@@ -1862,14 +1862,14 @@
         </p:nvSpPr>
         <p:spPr>
           <a:xfrm>
-            <a:off x="8961120" y="-2011680"/>
-            <a:ext cx="5669280" cy="5669280"/>
+            <a:off x="-2011680" y="4206240"/>
+            <a:ext cx="5486400" cy="5486400"/>
           </a:xfrm>
           <a:prstGeom prst="ellipse">
             <a:avLst/>
           </a:prstGeom>
           <a:solidFill>
-            <a:srgbClr val="2E7D46"/>
+            <a:srgbClr val="236B30"/>
           </a:solidFill>
           <a:ln/>
         </p:spPr>
@@ -1882,21 +1882,50 @@
         </p:nvSpPr>
         <p:spPr>
           <a:xfrm>
-            <a:off x="10424160" y="3840480"/>
-            <a:ext cx="4206240" cy="4206240"/>
+            <a:off x="9966960" y="-2194560"/>
+            <a:ext cx="4937760" cy="4937760"/>
           </a:xfrm>
           <a:prstGeom prst="ellipse">
             <a:avLst/>
           </a:prstGeom>
           <a:solidFill>
-            <a:srgbClr val="234E31"/>
+            <a:srgbClr val="0F3316"/>
           </a:solidFill>
           <a:ln/>
+        </p:spPr>
+      </p:sp>
+      <p:sp>
+        <p:nvSpPr>
+          <p:cNvPr id="4" name="Shape 2"/>
+          <p:cNvSpPr/>
+          <p:nvPr/>
+        </p:nvSpPr>
+        <p:spPr>
+          <a:xfrm>
+            <a:off x="7269480" y="1554480"/>
+            <a:ext cx="4389120" cy="3108960"/>
+          </a:xfrm>
+          <a:prstGeom prst="roundRect">
+            <a:avLst>
+              <a:gd name="adj" fmla="val 4706"/>
+            </a:avLst>
+          </a:prstGeom>
+          <a:solidFill>
+            <a:srgbClr val="F4EDDD"/>
+          </a:solidFill>
+          <a:ln/>
+          <a:effectLst>
+            <a:outerShdw sx="100000" sy="100000" kx="0" ky="0" algn="bl" rotWithShape="0" blurRad="114300" dist="38100" dir="5400000">
+              <a:srgbClr val="8AA090">
+                <a:alpha val="35000"/>
+              </a:srgbClr>
+            </a:outerShdw>
+          </a:effectLst>
         </p:spPr>
       </p:sp>
       <p:pic>
         <p:nvPicPr>
-          <p:cNvPr id="4" name="Image 0" descr="/tmp/claude-0/-home-user-n8n/e6b51ae7-6c99-5683-8277-7db523f0061c/scratchpad/huongdan/logo.png">    </p:cNvPr>
+          <p:cNvPr id="5" name="Image 0" descr="/tmp/claude-0/-home-user-n8n/e6b51ae7-6c99-5683-8277-7db523f0061c/scratchpad/huongdan/company_logo.png">    </p:cNvPr>
           <p:cNvPicPr>
             <a:picLocks noChangeAspect="1"/>
           </p:cNvPicPr>
@@ -1910,8 +1939,8 @@
         </p:blipFill>
         <p:spPr>
           <a:xfrm>
-            <a:off x="640080" y="457200"/>
-            <a:ext cx="1463040" cy="1463040"/>
+            <a:off x="7543800" y="1810512"/>
+            <a:ext cx="3840480" cy="2560320"/>
           </a:xfrm>
           <a:prstGeom prst="rect">
             <a:avLst/>
@@ -1920,32 +1949,32 @@
       </p:pic>
       <p:sp>
         <p:nvSpPr>
-          <p:cNvPr id="5" name="Text 2"/>
-          <p:cNvSpPr/>
-          <p:nvPr/>
-        </p:nvSpPr>
-        <p:spPr>
-          <a:xfrm>
-            <a:off x="685800" y="1874520"/>
-            <a:ext cx="10058400" cy="640080"/>
-          </a:xfrm>
-          <a:prstGeom prst="rect">
-            <a:avLst/>
-          </a:prstGeom>
-          <a:noFill/>
-          <a:ln/>
-        </p:spPr>
-        <p:txBody>
-          <a:bodyPr wrap="square" rtlCol="0" anchor="ctr"/>
-          <a:lstStyle/>
-          <a:p>
-            <a:pPr indent="0" marL="0">
-              <a:buNone/>
-            </a:pPr>
-            <a:r>
-              <a:rPr lang="en-US" sz="2200" b="1" spc="300" kern="0" dirty="0">
-                <a:solidFill>
-                  <a:srgbClr val="E0A83B"/>
+          <p:cNvPr id="6" name="Text 3"/>
+          <p:cNvSpPr/>
+          <p:nvPr/>
+        </p:nvSpPr>
+        <p:spPr>
+          <a:xfrm>
+            <a:off x="685800" y="1645920"/>
+            <a:ext cx="6400800" cy="457200"/>
+          </a:xfrm>
+          <a:prstGeom prst="rect">
+            <a:avLst/>
+          </a:prstGeom>
+          <a:noFill/>
+          <a:ln/>
+        </p:spPr>
+        <p:txBody>
+          <a:bodyPr wrap="square" rtlCol="0" anchor="ctr"/>
+          <a:lstStyle/>
+          <a:p>
+            <a:pPr indent="0" marL="0">
+              <a:buNone/>
+            </a:pPr>
+            <a:r>
+              <a:rPr lang="en-US" sz="1700" b="1" spc="300" kern="0" dirty="0">
+                <a:solidFill>
+                  <a:srgbClr val="D3AF2D"/>
                 </a:solidFill>
                 <a:latin typeface="Calibri" pitchFamily="34" charset="0"/>
                 <a:ea typeface="Calibri" pitchFamily="34" charset="-122"/>
@@ -1953,36 +1982,39 @@
               </a:rPr>
               <a:t>SỔ TAY HƯỚNG DẪN</a:t>
             </a:r>
-            <a:endParaRPr lang="en-US" sz="2200" dirty="0"/>
-          </a:p>
-        </p:txBody>
-      </p:sp>
-      <p:sp>
-        <p:nvSpPr>
-          <p:cNvPr id="6" name="Text 3"/>
-          <p:cNvSpPr/>
-          <p:nvPr/>
-        </p:nvSpPr>
-        <p:spPr>
-          <a:xfrm>
-            <a:off x="640080" y="2377440"/>
-            <a:ext cx="10972800" cy="1371600"/>
-          </a:xfrm>
-          <a:prstGeom prst="rect">
-            <a:avLst/>
-          </a:prstGeom>
-          <a:noFill/>
-          <a:ln/>
-        </p:spPr>
-        <p:txBody>
-          <a:bodyPr wrap="square" rtlCol="0" anchor="ctr"/>
-          <a:lstStyle/>
-          <a:p>
-            <a:pPr indent="0" marL="0">
-              <a:buNone/>
-            </a:pPr>
-            <a:r>
-              <a:rPr lang="en-US" sz="5200" b="1" dirty="0">
+            <a:endParaRPr lang="en-US" sz="1700" dirty="0"/>
+          </a:p>
+        </p:txBody>
+      </p:sp>
+      <p:sp>
+        <p:nvSpPr>
+          <p:cNvPr id="7" name="Text 4"/>
+          <p:cNvSpPr/>
+          <p:nvPr/>
+        </p:nvSpPr>
+        <p:spPr>
+          <a:xfrm>
+            <a:off x="640080" y="2121408"/>
+            <a:ext cx="6492240" cy="1554480"/>
+          </a:xfrm>
+          <a:prstGeom prst="rect">
+            <a:avLst/>
+          </a:prstGeom>
+          <a:noFill/>
+          <a:ln/>
+        </p:spPr>
+        <p:txBody>
+          <a:bodyPr wrap="square" rtlCol="0" anchor="ctr"/>
+          <a:lstStyle/>
+          <a:p>
+            <a:pPr indent="0" marL="0">
+              <a:lnSpc>
+                <a:spcPct val="98000"/>
+              </a:lnSpc>
+              <a:buNone/>
+            </a:pPr>
+            <a:r>
+              <a:rPr lang="en-US" sz="4100" b="1" dirty="0">
                 <a:solidFill>
                   <a:srgbClr val="FFFFFF"/>
                 </a:solidFill>
@@ -1990,22 +2022,42 @@
                 <a:ea typeface="Cambria" pitchFamily="34" charset="-122"/>
                 <a:cs typeface="Cambria" pitchFamily="34" charset="-120"/>
               </a:rPr>
-              <a:t>MINI APP THẠNH HƯƠNG</a:t>
-            </a:r>
-            <a:endParaRPr lang="en-US" sz="5200" dirty="0"/>
-          </a:p>
-        </p:txBody>
-      </p:sp>
-      <p:sp>
-        <p:nvSpPr>
-          <p:cNvPr id="7" name="Text 4"/>
+              <a:t>MINI APP</a:t>
+            </a:r>
+            <a:endParaRPr lang="en-US" sz="4100" dirty="0"/>
+          </a:p>
+          <a:p>
+            <a:pPr indent="0" marL="0">
+              <a:lnSpc>
+                <a:spcPct val="98000"/>
+              </a:lnSpc>
+              <a:buNone/>
+            </a:pPr>
+            <a:r>
+              <a:rPr lang="en-US" sz="4100" b="1" dirty="0">
+                <a:solidFill>
+                  <a:srgbClr val="FFFFFF"/>
+                </a:solidFill>
+                <a:latin typeface="Cambria" pitchFamily="34" charset="0"/>
+                <a:ea typeface="Cambria" pitchFamily="34" charset="-122"/>
+                <a:cs typeface="Cambria" pitchFamily="34" charset="-120"/>
+              </a:rPr>
+              <a:t>THẠNH HƯƠNG</a:t>
+            </a:r>
+            <a:endParaRPr lang="en-US" sz="4100" dirty="0"/>
+          </a:p>
+        </p:txBody>
+      </p:sp>
+      <p:sp>
+        <p:nvSpPr>
+          <p:cNvPr id="8" name="Text 5"/>
           <p:cNvSpPr/>
           <p:nvPr/>
         </p:nvSpPr>
         <p:spPr>
           <a:xfrm>
             <a:off x="685800" y="3794760"/>
-            <a:ext cx="8686800" cy="914400"/>
+            <a:ext cx="6309360" cy="914400"/>
           </a:xfrm>
           <a:prstGeom prst="rect">
             <a:avLst/>
@@ -2024,7 +2076,7 @@
               <a:buNone/>
             </a:pPr>
             <a:r>
-              <a:rPr lang="en-US" sz="1600" dirty="0">
+              <a:rPr lang="en-US" sz="1450" dirty="0">
                 <a:solidFill>
                   <a:srgbClr val="D9E6DC"/>
                 </a:solidFill>
@@ -2032,141 +2084,160 @@
                 <a:ea typeface="Calibri" pitchFamily="34" charset="-122"/>
                 <a:cs typeface="Calibri" pitchFamily="34" charset="-120"/>
               </a:rPr>
-              <a:t>Trợ lý Telegram giúp nhập liệu tự động: đọc căn cước, phiếu cân,</a:t>
-            </a:r>
-            <a:endParaRPr lang="en-US" sz="1600" dirty="0"/>
-          </a:p>
-          <a:p>
-            <a:pPr indent="0" marL="0">
-              <a:lnSpc>
-                <a:spcPct val="115000"/>
-              </a:lnSpc>
-              <a:buNone/>
-            </a:pPr>
-            <a:r>
-              <a:rPr lang="en-US" sz="1600" dirty="0">
-                <a:solidFill>
-                  <a:srgbClr val="D9E6DC"/>
+              <a:t>Trợ lý Telegram giúp nhập liệu tự động: đọc căn cước, phiếu cân, ghi sổ mua lúa — chỉ bằng cách chụp ảnh và bấm nút.</a:t>
+            </a:r>
+            <a:endParaRPr lang="en-US" sz="1450" dirty="0"/>
+          </a:p>
+        </p:txBody>
+      </p:sp>
+      <p:sp>
+        <p:nvSpPr>
+          <p:cNvPr id="9" name="Shape 6"/>
+          <p:cNvSpPr/>
+          <p:nvPr/>
+        </p:nvSpPr>
+        <p:spPr>
+          <a:xfrm>
+            <a:off x="685800" y="4846320"/>
+            <a:ext cx="4846320" cy="658368"/>
+          </a:xfrm>
+          <a:prstGeom prst="roundRect">
+            <a:avLst>
+              <a:gd name="adj" fmla="val 13889"/>
+            </a:avLst>
+          </a:prstGeom>
+          <a:solidFill>
+            <a:srgbClr val="D3AF2D"/>
+          </a:solidFill>
+          <a:ln/>
+        </p:spPr>
+      </p:sp>
+      <p:sp>
+        <p:nvSpPr>
+          <p:cNvPr id="10" name="Text 7"/>
+          <p:cNvSpPr/>
+          <p:nvPr/>
+        </p:nvSpPr>
+        <p:spPr>
+          <a:xfrm>
+            <a:off x="685800" y="4846320"/>
+            <a:ext cx="4846320" cy="658368"/>
+          </a:xfrm>
+          <a:prstGeom prst="rect">
+            <a:avLst/>
+          </a:prstGeom>
+          <a:noFill/>
+          <a:ln/>
+        </p:spPr>
+        <p:txBody>
+          <a:bodyPr wrap="square" rtlCol="0" anchor="ctr"/>
+          <a:lstStyle/>
+          <a:p>
+            <a:pPr algn="ctr" indent="0" marL="0">
+              <a:buNone/>
+            </a:pPr>
+            <a:r>
+              <a:rPr lang="en-US" sz="1400" b="1" dirty="0">
+                <a:solidFill>
+                  <a:srgbClr val="1B2A20"/>
                 </a:solidFill>
                 <a:latin typeface="Calibri" pitchFamily="34" charset="0"/>
                 <a:ea typeface="Calibri" pitchFamily="34" charset="-122"/>
                 <a:cs typeface="Calibri" pitchFamily="34" charset="-120"/>
               </a:rPr>
-              <a:t>ghi sổ mua lúa — chỉ bằng cách chụp ảnh và bấm nút.</a:t>
-            </a:r>
-            <a:endParaRPr lang="en-US" sz="1600" dirty="0"/>
-          </a:p>
-        </p:txBody>
-      </p:sp>
-      <p:sp>
-        <p:nvSpPr>
-          <p:cNvPr id="8" name="Shape 5"/>
-          <p:cNvSpPr/>
-          <p:nvPr/>
-        </p:nvSpPr>
-        <p:spPr>
-          <a:xfrm>
-            <a:off x="685800" y="5029200"/>
-            <a:ext cx="4754880" cy="685800"/>
-          </a:xfrm>
-          <a:prstGeom prst="roundRect">
-            <a:avLst>
-              <a:gd name="adj" fmla="val 13333"/>
-            </a:avLst>
-          </a:prstGeom>
-          <a:solidFill>
-            <a:srgbClr val="E0A83B"/>
-          </a:solidFill>
-          <a:ln/>
-        </p:spPr>
-      </p:sp>
-      <p:sp>
-        <p:nvSpPr>
-          <p:cNvPr id="9" name="Text 6"/>
-          <p:cNvSpPr/>
-          <p:nvPr/>
-        </p:nvSpPr>
-        <p:spPr>
-          <a:xfrm>
-            <a:off x="685800" y="5029200"/>
-            <a:ext cx="4754880" cy="685800"/>
-          </a:xfrm>
-          <a:prstGeom prst="rect">
-            <a:avLst/>
-          </a:prstGeom>
-          <a:noFill/>
-          <a:ln/>
-        </p:spPr>
-        <p:txBody>
-          <a:bodyPr wrap="square" rtlCol="0" anchor="ctr"/>
-          <a:lstStyle/>
-          <a:p>
-            <a:pPr algn="ctr" indent="0" marL="0">
-              <a:buNone/>
-            </a:pPr>
-            <a:r>
-              <a:rPr lang="en-US" sz="1400" b="1" dirty="0">
-                <a:solidFill>
-                  <a:srgbClr val="1B2A20"/>
+              <a:t>📘  Tài liệu hướng dẫn nhân viên</a:t>
+            </a:r>
+            <a:endParaRPr lang="en-US" sz="1400" dirty="0"/>
+          </a:p>
+        </p:txBody>
+      </p:sp>
+      <p:sp>
+        <p:nvSpPr>
+          <p:cNvPr id="11" name="Text 8"/>
+          <p:cNvSpPr/>
+          <p:nvPr/>
+        </p:nvSpPr>
+        <p:spPr>
+          <a:xfrm>
+            <a:off x="685800" y="5852160"/>
+            <a:ext cx="10058400" cy="320040"/>
+          </a:xfrm>
+          <a:prstGeom prst="rect">
+            <a:avLst/>
+          </a:prstGeom>
+          <a:noFill/>
+          <a:ln/>
+        </p:spPr>
+        <p:txBody>
+          <a:bodyPr wrap="square" rtlCol="0" anchor="ctr"/>
+          <a:lstStyle/>
+          <a:p>
+            <a:pPr indent="0" marL="0">
+              <a:buNone/>
+            </a:pPr>
+            <a:r>
+              <a:rPr lang="en-US" sz="1300" b="1" spc="100" kern="0" dirty="0">
+                <a:solidFill>
+                  <a:srgbClr val="D3AF2D"/>
                 </a:solidFill>
                 <a:latin typeface="Calibri" pitchFamily="34" charset="0"/>
                 <a:ea typeface="Calibri" pitchFamily="34" charset="-122"/>
                 <a:cs typeface="Calibri" pitchFamily="34" charset="-120"/>
               </a:rPr>
-              <a:t>📘  Tài liệu hướng dẫn nhân viên</a:t>
-            </a:r>
-            <a:endParaRPr lang="en-US" sz="1400" dirty="0"/>
-          </a:p>
-        </p:txBody>
-      </p:sp>
-      <p:sp>
-        <p:nvSpPr>
-          <p:cNvPr id="10" name="Text 7"/>
-          <p:cNvSpPr/>
-          <p:nvPr/>
-        </p:nvSpPr>
-        <p:spPr>
-          <a:xfrm>
-            <a:off x="685800" y="5760720"/>
-            <a:ext cx="10058400" cy="320040"/>
-          </a:xfrm>
-          <a:prstGeom prst="rect">
-            <a:avLst/>
-          </a:prstGeom>
-          <a:noFill/>
-          <a:ln/>
-        </p:spPr>
-        <p:txBody>
-          <a:bodyPr wrap="square" rtlCol="0" anchor="ctr"/>
-          <a:lstStyle/>
-          <a:p>
-            <a:pPr indent="0" marL="0">
-              <a:buNone/>
-            </a:pPr>
-            <a:r>
-              <a:rPr lang="en-US" sz="1300" b="1" spc="100" kern="0" dirty="0">
-                <a:solidFill>
-                  <a:srgbClr val="E0A83B"/>
+              <a:t>CÔNG TY TNHH TM DV XNK THÀNH HƯNG</a:t>
+            </a:r>
+            <a:endParaRPr lang="en-US" sz="1300" dirty="0"/>
+          </a:p>
+        </p:txBody>
+      </p:sp>
+      <p:sp>
+        <p:nvSpPr>
+          <p:cNvPr id="12" name="Text 9"/>
+          <p:cNvSpPr/>
+          <p:nvPr/>
+        </p:nvSpPr>
+        <p:spPr>
+          <a:xfrm>
+            <a:off x="685800" y="6181344"/>
+            <a:ext cx="8229600" cy="274320"/>
+          </a:xfrm>
+          <a:prstGeom prst="rect">
+            <a:avLst/>
+          </a:prstGeom>
+          <a:noFill/>
+          <a:ln/>
+        </p:spPr>
+        <p:txBody>
+          <a:bodyPr wrap="square" rtlCol="0" anchor="ctr"/>
+          <a:lstStyle/>
+          <a:p>
+            <a:pPr indent="0" marL="0">
+              <a:buNone/>
+            </a:pPr>
+            <a:r>
+              <a:rPr lang="en-US" sz="1150" dirty="0">
+                <a:solidFill>
+                  <a:srgbClr val="B7CBBB"/>
                 </a:solidFill>
                 <a:latin typeface="Calibri" pitchFamily="34" charset="0"/>
                 <a:ea typeface="Calibri" pitchFamily="34" charset="-122"/>
                 <a:cs typeface="Calibri" pitchFamily="34" charset="-120"/>
               </a:rPr>
-              <a:t>CÔNG TY TNHH TM DV XNK THÀNH HƯNG</a:t>
-            </a:r>
-            <a:endParaRPr lang="en-US" sz="1300" dirty="0"/>
-          </a:p>
-        </p:txBody>
-      </p:sp>
-      <p:sp>
-        <p:nvSpPr>
-          <p:cNvPr id="11" name="Text 8"/>
-          <p:cNvSpPr/>
-          <p:nvPr/>
-        </p:nvSpPr>
-        <p:spPr>
-          <a:xfrm>
-            <a:off x="685800" y="6108192"/>
+              <a:t>Nhà máy Xay xát Gạo Thạnh Hương</a:t>
+            </a:r>
+            <a:endParaRPr lang="en-US" sz="1150" dirty="0"/>
+          </a:p>
+        </p:txBody>
+      </p:sp>
+      <p:sp>
+        <p:nvSpPr>
+          <p:cNvPr id="13" name="Text 10"/>
+          <p:cNvSpPr/>
+          <p:nvPr/>
+        </p:nvSpPr>
+        <p:spPr>
+          <a:xfrm>
+            <a:off x="685800" y="6455664"/>
             <a:ext cx="8229600" cy="274320"/>
           </a:xfrm>
           <a:prstGeom prst="rect">
@@ -2185,46 +2256,7 @@
             <a:r>
               <a:rPr lang="en-US" sz="1150" dirty="0">
                 <a:solidFill>
-                  <a:srgbClr val="AFC3B4"/>
-                </a:solidFill>
-                <a:latin typeface="Calibri" pitchFamily="34" charset="0"/>
-                <a:ea typeface="Calibri" pitchFamily="34" charset="-122"/>
-                <a:cs typeface="Calibri" pitchFamily="34" charset="-120"/>
-              </a:rPr>
-              <a:t>Nhà máy Xay xát Gạo Thạnh Hương</a:t>
-            </a:r>
-            <a:endParaRPr lang="en-US" sz="1150" dirty="0"/>
-          </a:p>
-        </p:txBody>
-      </p:sp>
-      <p:sp>
-        <p:nvSpPr>
-          <p:cNvPr id="12" name="Text 9"/>
-          <p:cNvSpPr/>
-          <p:nvPr/>
-        </p:nvSpPr>
-        <p:spPr>
-          <a:xfrm>
-            <a:off x="685800" y="6382512"/>
-            <a:ext cx="8229600" cy="274320"/>
-          </a:xfrm>
-          <a:prstGeom prst="rect">
-            <a:avLst/>
-          </a:prstGeom>
-          <a:noFill/>
-          <a:ln/>
-        </p:spPr>
-        <p:txBody>
-          <a:bodyPr wrap="square" rtlCol="0" anchor="ctr"/>
-          <a:lstStyle/>
-          <a:p>
-            <a:pPr indent="0" marL="0">
-              <a:buNone/>
-            </a:pPr>
-            <a:r>
-              <a:rPr lang="en-US" sz="1150" dirty="0">
-                <a:solidFill>
-                  <a:srgbClr val="AFC3B4"/>
+                  <a:srgbClr val="B7CBBB"/>
                 </a:solidFill>
                 <a:latin typeface="Calibri" pitchFamily="34" charset="0"/>
                 <a:ea typeface="Calibri" pitchFamily="34" charset="-122"/>
@@ -2309,7 +2341,7 @@
             <a:r>
               <a:rPr lang="en-US" sz="1300" b="1" spc="200" kern="0" dirty="0">
                 <a:solidFill>
-                  <a:srgbClr val="B9832B"/>
+                  <a:srgbClr val="9C7714"/>
                 </a:solidFill>
                 <a:latin typeface="Calibri" pitchFamily="34" charset="0"/>
                 <a:ea typeface="Calibri" pitchFamily="34" charset="-122"/>
@@ -2348,7 +2380,7 @@
             <a:r>
               <a:rPr lang="en-US" sz="3400" b="1" dirty="0">
                 <a:solidFill>
-                  <a:srgbClr val="1E4D2B"/>
+                  <a:srgbClr val="15451F"/>
                 </a:solidFill>
                 <a:latin typeface="Cambria" pitchFamily="34" charset="0"/>
                 <a:ea typeface="Cambria" pitchFamily="34" charset="-122"/>
@@ -2387,7 +2419,7 @@
             <a:r>
               <a:rPr lang="en-US" sz="1450" dirty="0">
                 <a:solidFill>
-                  <a:srgbClr val="5E6B60"/>
+                  <a:srgbClr val="55635A"/>
                 </a:solidFill>
                 <a:latin typeface="Calibri" pitchFamily="34" charset="0"/>
                 <a:ea typeface="Calibri" pitchFamily="34" charset="-122"/>
@@ -2416,7 +2448,7 @@
             </a:avLst>
           </a:prstGeom>
           <a:solidFill>
-            <a:srgbClr val="EFF4EE"/>
+            <a:srgbClr val="EDF3ED"/>
           </a:solidFill>
           <a:ln/>
           <a:effectLst>
@@ -2443,7 +2475,7 @@
             <a:avLst/>
           </a:prstGeom>
           <a:solidFill>
-            <a:srgbClr val="1E4D2B"/>
+            <a:srgbClr val="15451F"/>
           </a:solidFill>
           <a:ln/>
         </p:spPr>
@@ -2514,7 +2546,7 @@
             <a:r>
               <a:rPr lang="en-US" sz="1800" b="1" dirty="0">
                 <a:solidFill>
-                  <a:srgbClr val="1E4D2B"/>
+                  <a:srgbClr val="15451F"/>
                 </a:solidFill>
                 <a:latin typeface="Courier New" pitchFamily="34" charset="0"/>
                 <a:ea typeface="Courier New" pitchFamily="34" charset="-122"/>
@@ -2556,7 +2588,7 @@
             <a:r>
               <a:rPr lang="en-US" sz="1250" dirty="0">
                 <a:solidFill>
-                  <a:srgbClr val="5E6B60"/>
+                  <a:srgbClr val="55635A"/>
                 </a:solidFill>
                 <a:latin typeface="Calibri" pitchFamily="34" charset="0"/>
                 <a:ea typeface="Calibri" pitchFamily="34" charset="-122"/>
@@ -2585,7 +2617,7 @@
             </a:avLst>
           </a:prstGeom>
           <a:solidFill>
-            <a:srgbClr val="EFF4EE"/>
+            <a:srgbClr val="EDF3ED"/>
           </a:solidFill>
           <a:ln/>
           <a:effectLst>
@@ -2612,7 +2644,7 @@
             <a:avLst/>
           </a:prstGeom>
           <a:solidFill>
-            <a:srgbClr val="2E7D46"/>
+            <a:srgbClr val="236B30"/>
           </a:solidFill>
           <a:ln/>
         </p:spPr>
@@ -2683,7 +2715,7 @@
             <a:r>
               <a:rPr lang="en-US" sz="1800" b="1" dirty="0">
                 <a:solidFill>
-                  <a:srgbClr val="1E4D2B"/>
+                  <a:srgbClr val="15451F"/>
                 </a:solidFill>
                 <a:latin typeface="Courier New" pitchFamily="34" charset="0"/>
                 <a:ea typeface="Courier New" pitchFamily="34" charset="-122"/>
@@ -2725,7 +2757,7 @@
             <a:r>
               <a:rPr lang="en-US" sz="1250" dirty="0">
                 <a:solidFill>
-                  <a:srgbClr val="5E6B60"/>
+                  <a:srgbClr val="55635A"/>
                 </a:solidFill>
                 <a:latin typeface="Calibri" pitchFamily="34" charset="0"/>
                 <a:ea typeface="Calibri" pitchFamily="34" charset="-122"/>
@@ -2754,7 +2786,7 @@
             </a:avLst>
           </a:prstGeom>
           <a:solidFill>
-            <a:srgbClr val="EFF4EE"/>
+            <a:srgbClr val="EDF3ED"/>
           </a:solidFill>
           <a:ln/>
           <a:effectLst>
@@ -2781,7 +2813,7 @@
             <a:avLst/>
           </a:prstGeom>
           <a:solidFill>
-            <a:srgbClr val="B9832B"/>
+            <a:srgbClr val="9C7714"/>
           </a:solidFill>
           <a:ln/>
         </p:spPr>
@@ -2852,7 +2884,7 @@
             <a:r>
               <a:rPr lang="en-US" sz="1800" b="1" dirty="0">
                 <a:solidFill>
-                  <a:srgbClr val="1E4D2B"/>
+                  <a:srgbClr val="15451F"/>
                 </a:solidFill>
                 <a:latin typeface="Courier New" pitchFamily="34" charset="0"/>
                 <a:ea typeface="Courier New" pitchFamily="34" charset="-122"/>
@@ -2894,7 +2926,7 @@
             <a:r>
               <a:rPr lang="en-US" sz="1250" dirty="0">
                 <a:solidFill>
-                  <a:srgbClr val="5E6B60"/>
+                  <a:srgbClr val="55635A"/>
                 </a:solidFill>
                 <a:latin typeface="Calibri" pitchFamily="34" charset="0"/>
                 <a:ea typeface="Calibri" pitchFamily="34" charset="-122"/>
@@ -2933,7 +2965,7 @@
             <a:r>
               <a:rPr lang="en-US" sz="1300" i="1" dirty="0">
                 <a:solidFill>
-                  <a:srgbClr val="B9832B"/>
+                  <a:srgbClr val="9C7714"/>
                 </a:solidFill>
                 <a:latin typeface="Calibri" pitchFamily="34" charset="0"/>
                 <a:ea typeface="Calibri" pitchFamily="34" charset="-122"/>
@@ -2972,7 +3004,7 @@
             <a:r>
               <a:rPr lang="en-US" sz="900" dirty="0">
                 <a:solidFill>
-                  <a:srgbClr val="5E6B60"/>
+                  <a:srgbClr val="55635A"/>
                 </a:solidFill>
                 <a:latin typeface="Calibri" pitchFamily="34" charset="0"/>
                 <a:ea typeface="Calibri" pitchFamily="34" charset="-122"/>
@@ -3025,7 +3057,7 @@
             <a:r>
               <a:rPr lang="en-US" sz="1000" dirty="0">
                 <a:solidFill>
-                  <a:srgbClr val="5E6B60"/>
+                  <a:srgbClr val="55635A"/>
                 </a:solidFill>
                 <a:latin typeface="Calibri" pitchFamily="34" charset="0"/>
                 <a:ea typeface="Calibri" pitchFamily="34" charset="-122"/>
@@ -3096,7 +3128,7 @@
             <a:r>
               <a:rPr lang="en-US" sz="1300" b="1" spc="200" kern="0" dirty="0">
                 <a:solidFill>
-                  <a:srgbClr val="B9832B"/>
+                  <a:srgbClr val="9C7714"/>
                 </a:solidFill>
                 <a:latin typeface="Calibri" pitchFamily="34" charset="0"/>
                 <a:ea typeface="Calibri" pitchFamily="34" charset="-122"/>
@@ -3135,7 +3167,7 @@
             <a:r>
               <a:rPr lang="en-US" sz="3400" b="1" dirty="0">
                 <a:solidFill>
-                  <a:srgbClr val="1E4D2B"/>
+                  <a:srgbClr val="15451F"/>
                 </a:solidFill>
                 <a:latin typeface="Cambria" pitchFamily="34" charset="0"/>
                 <a:ea typeface="Cambria" pitchFamily="34" charset="-122"/>
@@ -3191,7 +3223,7 @@
             <a:avLst/>
           </a:prstGeom>
           <a:solidFill>
-            <a:srgbClr val="E0A83B"/>
+            <a:srgbClr val="D3AF2D"/>
           </a:solidFill>
           <a:ln/>
         </p:spPr>
@@ -3262,7 +3294,7 @@
             <a:r>
               <a:rPr lang="en-US" sz="1550" b="1" dirty="0">
                 <a:solidFill>
-                  <a:srgbClr val="1E4D2B"/>
+                  <a:srgbClr val="15451F"/>
                 </a:solidFill>
                 <a:latin typeface="Cambria" pitchFamily="34" charset="0"/>
                 <a:ea typeface="Cambria" pitchFamily="34" charset="-122"/>
@@ -3304,7 +3336,7 @@
             <a:r>
               <a:rPr lang="en-US" sz="1250" dirty="0">
                 <a:solidFill>
-                  <a:srgbClr val="5E6B60"/>
+                  <a:srgbClr val="55635A"/>
                 </a:solidFill>
                 <a:latin typeface="Calibri" pitchFamily="34" charset="0"/>
                 <a:ea typeface="Calibri" pitchFamily="34" charset="-122"/>
@@ -3333,7 +3365,7 @@
             </a:avLst>
           </a:prstGeom>
           <a:solidFill>
-            <a:srgbClr val="EFF4EE"/>
+            <a:srgbClr val="EDF3ED"/>
           </a:solidFill>
           <a:ln/>
           <a:effectLst>
@@ -3360,7 +3392,7 @@
             <a:avLst/>
           </a:prstGeom>
           <a:solidFill>
-            <a:srgbClr val="E0A83B"/>
+            <a:srgbClr val="D3AF2D"/>
           </a:solidFill>
           <a:ln/>
         </p:spPr>
@@ -3431,7 +3463,7 @@
             <a:r>
               <a:rPr lang="en-US" sz="1550" b="1" dirty="0">
                 <a:solidFill>
-                  <a:srgbClr val="1E4D2B"/>
+                  <a:srgbClr val="15451F"/>
                 </a:solidFill>
                 <a:latin typeface="Cambria" pitchFamily="34" charset="0"/>
                 <a:ea typeface="Cambria" pitchFamily="34" charset="-122"/>
@@ -3473,7 +3505,7 @@
             <a:r>
               <a:rPr lang="en-US" sz="1250" dirty="0">
                 <a:solidFill>
-                  <a:srgbClr val="5E6B60"/>
+                  <a:srgbClr val="55635A"/>
                 </a:solidFill>
                 <a:latin typeface="Calibri" pitchFamily="34" charset="0"/>
                 <a:ea typeface="Calibri" pitchFamily="34" charset="-122"/>
@@ -3529,7 +3561,7 @@
             <a:avLst/>
           </a:prstGeom>
           <a:solidFill>
-            <a:srgbClr val="E0A83B"/>
+            <a:srgbClr val="D3AF2D"/>
           </a:solidFill>
           <a:ln/>
         </p:spPr>
@@ -3600,7 +3632,7 @@
             <a:r>
               <a:rPr lang="en-US" sz="1550" b="1" dirty="0">
                 <a:solidFill>
-                  <a:srgbClr val="1E4D2B"/>
+                  <a:srgbClr val="15451F"/>
                 </a:solidFill>
                 <a:latin typeface="Cambria" pitchFamily="34" charset="0"/>
                 <a:ea typeface="Cambria" pitchFamily="34" charset="-122"/>
@@ -3642,7 +3674,7 @@
             <a:r>
               <a:rPr lang="en-US" sz="1250" dirty="0">
                 <a:solidFill>
-                  <a:srgbClr val="5E6B60"/>
+                  <a:srgbClr val="55635A"/>
                 </a:solidFill>
                 <a:latin typeface="Calibri" pitchFamily="34" charset="0"/>
                 <a:ea typeface="Calibri" pitchFamily="34" charset="-122"/>
@@ -3671,7 +3703,7 @@
             </a:avLst>
           </a:prstGeom>
           <a:solidFill>
-            <a:srgbClr val="EFF4EE"/>
+            <a:srgbClr val="EDF3ED"/>
           </a:solidFill>
           <a:ln/>
           <a:effectLst>
@@ -3698,7 +3730,7 @@
             <a:avLst/>
           </a:prstGeom>
           <a:solidFill>
-            <a:srgbClr val="E0A83B"/>
+            <a:srgbClr val="D3AF2D"/>
           </a:solidFill>
           <a:ln/>
         </p:spPr>
@@ -3769,7 +3801,7 @@
             <a:r>
               <a:rPr lang="en-US" sz="1550" b="1" dirty="0">
                 <a:solidFill>
-                  <a:srgbClr val="1E4D2B"/>
+                  <a:srgbClr val="15451F"/>
                 </a:solidFill>
                 <a:latin typeface="Cambria" pitchFamily="34" charset="0"/>
                 <a:ea typeface="Cambria" pitchFamily="34" charset="-122"/>
@@ -3811,7 +3843,7 @@
             <a:r>
               <a:rPr lang="en-US" sz="1250" dirty="0">
                 <a:solidFill>
-                  <a:srgbClr val="5E6B60"/>
+                  <a:srgbClr val="55635A"/>
                 </a:solidFill>
                 <a:latin typeface="Calibri" pitchFamily="34" charset="0"/>
                 <a:ea typeface="Calibri" pitchFamily="34" charset="-122"/>
@@ -3850,7 +3882,7 @@
             <a:r>
               <a:rPr lang="en-US" sz="900" dirty="0">
                 <a:solidFill>
-                  <a:srgbClr val="5E6B60"/>
+                  <a:srgbClr val="55635A"/>
                 </a:solidFill>
                 <a:latin typeface="Calibri" pitchFamily="34" charset="0"/>
                 <a:ea typeface="Calibri" pitchFamily="34" charset="-122"/>
@@ -3903,7 +3935,7 @@
             <a:r>
               <a:rPr lang="en-US" sz="1000" dirty="0">
                 <a:solidFill>
-                  <a:srgbClr val="5E6B60"/>
+                  <a:srgbClr val="55635A"/>
                 </a:solidFill>
                 <a:latin typeface="Calibri" pitchFamily="34" charset="0"/>
                 <a:ea typeface="Calibri" pitchFamily="34" charset="-122"/>
@@ -3929,7 +3961,7 @@
     <p:bg>
       <p:bgPr>
         <a:solidFill>
-          <a:srgbClr val="1E4D2B"/>
+          <a:srgbClr val="15451F"/>
         </a:solidFill>
       </p:bgPr>
     </p:bg>
@@ -3962,7 +3994,7 @@
             <a:avLst/>
           </a:prstGeom>
           <a:solidFill>
-            <a:srgbClr val="2E7D46"/>
+            <a:srgbClr val="236B30"/>
           </a:solidFill>
           <a:ln/>
         </p:spPr>
@@ -3982,552 +4014,29 @@
             <a:avLst/>
           </a:prstGeom>
           <a:solidFill>
-            <a:srgbClr val="234E31"/>
+            <a:srgbClr val="0F3316"/>
           </a:solidFill>
           <a:ln/>
         </p:spPr>
       </p:sp>
       <p:sp>
         <p:nvSpPr>
-          <p:cNvPr id="4" name="Text 2"/>
-          <p:cNvSpPr/>
-          <p:nvPr/>
-        </p:nvSpPr>
-        <p:spPr>
-          <a:xfrm>
-            <a:off x="640080" y="640080"/>
-            <a:ext cx="10058400" cy="548640"/>
-          </a:xfrm>
-          <a:prstGeom prst="rect">
-            <a:avLst/>
-          </a:prstGeom>
-          <a:noFill/>
-          <a:ln/>
-        </p:spPr>
-        <p:txBody>
-          <a:bodyPr wrap="square" rtlCol="0" anchor="ctr"/>
-          <a:lstStyle/>
-          <a:p>
-            <a:pPr indent="0" marL="0">
-              <a:buNone/>
-            </a:pPr>
-            <a:r>
-              <a:rPr lang="en-US" sz="1600" b="1" spc="200" kern="0" dirty="0">
-                <a:solidFill>
-                  <a:srgbClr val="E0A83B"/>
-                </a:solidFill>
-                <a:latin typeface="Calibri" pitchFamily="34" charset="0"/>
-                <a:ea typeface="Calibri" pitchFamily="34" charset="-122"/>
-                <a:cs typeface="Calibri" pitchFamily="34" charset="-120"/>
-              </a:rPr>
-              <a:t>🔒  QUY TẮC VÀNG</a:t>
-            </a:r>
-            <a:endParaRPr lang="en-US" sz="1600" dirty="0"/>
-          </a:p>
-        </p:txBody>
-      </p:sp>
-      <p:sp>
-        <p:nvSpPr>
-          <p:cNvPr id="5" name="Text 3"/>
-          <p:cNvSpPr/>
-          <p:nvPr/>
-        </p:nvSpPr>
-        <p:spPr>
-          <a:xfrm>
-            <a:off x="640080" y="1143000"/>
-            <a:ext cx="10058400" cy="822960"/>
-          </a:xfrm>
-          <a:prstGeom prst="rect">
-            <a:avLst/>
-          </a:prstGeom>
-          <a:noFill/>
-          <a:ln/>
-        </p:spPr>
-        <p:txBody>
-          <a:bodyPr wrap="square" rtlCol="0" anchor="ctr"/>
-          <a:lstStyle/>
-          <a:p>
-            <a:pPr indent="0" marL="0">
-              <a:buNone/>
-            </a:pPr>
-            <a:r>
-              <a:rPr lang="en-US" sz="3600" b="1" dirty="0">
-                <a:solidFill>
-                  <a:srgbClr val="FFFFFF"/>
-                </a:solidFill>
-                <a:latin typeface="Cambria" pitchFamily="34" charset="0"/>
-                <a:ea typeface="Cambria" pitchFamily="34" charset="-122"/>
-                <a:cs typeface="Cambria" pitchFamily="34" charset="-120"/>
-              </a:rPr>
-              <a:t>Giữ an toàn cho dữ liệu</a:t>
-            </a:r>
-            <a:endParaRPr lang="en-US" sz="3600" dirty="0"/>
-          </a:p>
-        </p:txBody>
-      </p:sp>
-      <p:sp>
-        <p:nvSpPr>
-          <p:cNvPr id="6" name="Shape 4"/>
-          <p:cNvSpPr/>
-          <p:nvPr/>
-        </p:nvSpPr>
-        <p:spPr>
-          <a:xfrm>
-            <a:off x="640080" y="2240280"/>
-            <a:ext cx="502920" cy="502920"/>
-          </a:xfrm>
-          <a:prstGeom prst="ellipse">
-            <a:avLst/>
-          </a:prstGeom>
-          <a:solidFill>
-            <a:srgbClr val="E0A83B"/>
-          </a:solidFill>
-          <a:ln/>
-        </p:spPr>
-      </p:sp>
-      <p:sp>
-        <p:nvSpPr>
-          <p:cNvPr id="7" name="Text 5"/>
-          <p:cNvSpPr/>
-          <p:nvPr/>
-        </p:nvSpPr>
-        <p:spPr>
-          <a:xfrm>
-            <a:off x="640080" y="2240280"/>
-            <a:ext cx="502920" cy="502920"/>
-          </a:xfrm>
-          <a:prstGeom prst="rect">
-            <a:avLst/>
-          </a:prstGeom>
-          <a:noFill/>
-          <a:ln/>
-        </p:spPr>
-        <p:txBody>
-          <a:bodyPr wrap="square" rtlCol="0" anchor="ctr"/>
-          <a:lstStyle/>
-          <a:p>
-            <a:pPr algn="ctr" indent="0" marL="0">
-              <a:buNone/>
-            </a:pPr>
-            <a:r>
-              <a:rPr lang="en-US" sz="1800" b="1" dirty="0">
-                <a:solidFill>
-                  <a:srgbClr val="1B2A20"/>
-                </a:solidFill>
-                <a:latin typeface="Cambria" pitchFamily="34" charset="0"/>
-                <a:ea typeface="Cambria" pitchFamily="34" charset="-122"/>
-                <a:cs typeface="Cambria" pitchFamily="34" charset="-120"/>
-              </a:rPr>
-              <a:t>1</a:t>
-            </a:r>
-            <a:endParaRPr lang="en-US" sz="1800" dirty="0"/>
-          </a:p>
-        </p:txBody>
-      </p:sp>
-      <p:sp>
-        <p:nvSpPr>
-          <p:cNvPr id="8" name="Text 6"/>
-          <p:cNvSpPr/>
-          <p:nvPr/>
-        </p:nvSpPr>
-        <p:spPr>
-          <a:xfrm>
-            <a:off x="1371600" y="2240280"/>
-            <a:ext cx="8686800" cy="548640"/>
-          </a:xfrm>
-          <a:prstGeom prst="rect">
-            <a:avLst/>
-          </a:prstGeom>
-          <a:noFill/>
-          <a:ln/>
-        </p:spPr>
-        <p:txBody>
-          <a:bodyPr wrap="square" rtlCol="0" anchor="ctr"/>
-          <a:lstStyle/>
-          <a:p>
-            <a:pPr indent="0" marL="0">
-              <a:buNone/>
-            </a:pPr>
-            <a:r>
-              <a:rPr lang="en-US" sz="1600" dirty="0">
-                <a:solidFill>
-                  <a:srgbClr val="E8F1EA"/>
-                </a:solidFill>
-                <a:latin typeface="Calibri" pitchFamily="34" charset="0"/>
-                <a:ea typeface="Calibri" pitchFamily="34" charset="-122"/>
-                <a:cs typeface="Calibri" pitchFamily="34" charset="-120"/>
-              </a:rPr>
-              <a:t>Không chia sẻ đường link bot cho người ngoài công ty.</a:t>
-            </a:r>
-            <a:endParaRPr lang="en-US" sz="1600" dirty="0"/>
-          </a:p>
-        </p:txBody>
-      </p:sp>
-      <p:sp>
-        <p:nvSpPr>
-          <p:cNvPr id="9" name="Shape 7"/>
-          <p:cNvSpPr/>
-          <p:nvPr/>
-        </p:nvSpPr>
-        <p:spPr>
-          <a:xfrm>
-            <a:off x="640080" y="3017520"/>
-            <a:ext cx="502920" cy="502920"/>
-          </a:xfrm>
-          <a:prstGeom prst="ellipse">
-            <a:avLst/>
-          </a:prstGeom>
-          <a:solidFill>
-            <a:srgbClr val="E0A83B"/>
-          </a:solidFill>
-          <a:ln/>
-        </p:spPr>
-      </p:sp>
-      <p:sp>
-        <p:nvSpPr>
-          <p:cNvPr id="10" name="Text 8"/>
-          <p:cNvSpPr/>
-          <p:nvPr/>
-        </p:nvSpPr>
-        <p:spPr>
-          <a:xfrm>
-            <a:off x="640080" y="3017520"/>
-            <a:ext cx="502920" cy="502920"/>
-          </a:xfrm>
-          <a:prstGeom prst="rect">
-            <a:avLst/>
-          </a:prstGeom>
-          <a:noFill/>
-          <a:ln/>
-        </p:spPr>
-        <p:txBody>
-          <a:bodyPr wrap="square" rtlCol="0" anchor="ctr"/>
-          <a:lstStyle/>
-          <a:p>
-            <a:pPr algn="ctr" indent="0" marL="0">
-              <a:buNone/>
-            </a:pPr>
-            <a:r>
-              <a:rPr lang="en-US" sz="1800" b="1" dirty="0">
-                <a:solidFill>
-                  <a:srgbClr val="1B2A20"/>
-                </a:solidFill>
-                <a:latin typeface="Cambria" pitchFamily="34" charset="0"/>
-                <a:ea typeface="Cambria" pitchFamily="34" charset="-122"/>
-                <a:cs typeface="Cambria" pitchFamily="34" charset="-120"/>
-              </a:rPr>
-              <a:t>2</a:t>
-            </a:r>
-            <a:endParaRPr lang="en-US" sz="1800" dirty="0"/>
-          </a:p>
-        </p:txBody>
-      </p:sp>
-      <p:sp>
-        <p:nvSpPr>
-          <p:cNvPr id="11" name="Text 9"/>
-          <p:cNvSpPr/>
-          <p:nvPr/>
-        </p:nvSpPr>
-        <p:spPr>
-          <a:xfrm>
-            <a:off x="1371600" y="3017520"/>
-            <a:ext cx="8686800" cy="548640"/>
-          </a:xfrm>
-          <a:prstGeom prst="rect">
-            <a:avLst/>
-          </a:prstGeom>
-          <a:noFill/>
-          <a:ln/>
-        </p:spPr>
-        <p:txBody>
-          <a:bodyPr wrap="square" rtlCol="0" anchor="ctr"/>
-          <a:lstStyle/>
-          <a:p>
-            <a:pPr indent="0" marL="0">
-              <a:buNone/>
-            </a:pPr>
-            <a:r>
-              <a:rPr lang="en-US" sz="1600" dirty="0">
-                <a:solidFill>
-                  <a:srgbClr val="E8F1EA"/>
-                </a:solidFill>
-                <a:latin typeface="Calibri" pitchFamily="34" charset="0"/>
-                <a:ea typeface="Calibri" pitchFamily="34" charset="-122"/>
-                <a:cs typeface="Calibri" pitchFamily="34" charset="-120"/>
-              </a:rPr>
-              <a:t>Không dùng ảnh căn cước cho mục đích ngoài công việc.</a:t>
-            </a:r>
-            <a:endParaRPr lang="en-US" sz="1600" dirty="0"/>
-          </a:p>
-        </p:txBody>
-      </p:sp>
-      <p:sp>
-        <p:nvSpPr>
-          <p:cNvPr id="12" name="Shape 10"/>
-          <p:cNvSpPr/>
-          <p:nvPr/>
-        </p:nvSpPr>
-        <p:spPr>
-          <a:xfrm>
-            <a:off x="640080" y="3794760"/>
-            <a:ext cx="502920" cy="502920"/>
-          </a:xfrm>
-          <a:prstGeom prst="ellipse">
-            <a:avLst/>
-          </a:prstGeom>
-          <a:solidFill>
-            <a:srgbClr val="E0A83B"/>
-          </a:solidFill>
-          <a:ln/>
-        </p:spPr>
-      </p:sp>
-      <p:sp>
-        <p:nvSpPr>
-          <p:cNvPr id="13" name="Text 11"/>
-          <p:cNvSpPr/>
-          <p:nvPr/>
-        </p:nvSpPr>
-        <p:spPr>
-          <a:xfrm>
-            <a:off x="640080" y="3794760"/>
-            <a:ext cx="502920" cy="502920"/>
-          </a:xfrm>
-          <a:prstGeom prst="rect">
-            <a:avLst/>
-          </a:prstGeom>
-          <a:noFill/>
-          <a:ln/>
-        </p:spPr>
-        <p:txBody>
-          <a:bodyPr wrap="square" rtlCol="0" anchor="ctr"/>
-          <a:lstStyle/>
-          <a:p>
-            <a:pPr algn="ctr" indent="0" marL="0">
-              <a:buNone/>
-            </a:pPr>
-            <a:r>
-              <a:rPr lang="en-US" sz="1800" b="1" dirty="0">
-                <a:solidFill>
-                  <a:srgbClr val="1B2A20"/>
-                </a:solidFill>
-                <a:latin typeface="Cambria" pitchFamily="34" charset="0"/>
-                <a:ea typeface="Cambria" pitchFamily="34" charset="-122"/>
-                <a:cs typeface="Cambria" pitchFamily="34" charset="-120"/>
-              </a:rPr>
-              <a:t>3</a:t>
-            </a:r>
-            <a:endParaRPr lang="en-US" sz="1800" dirty="0"/>
-          </a:p>
-        </p:txBody>
-      </p:sp>
-      <p:sp>
-        <p:nvSpPr>
-          <p:cNvPr id="14" name="Text 12"/>
-          <p:cNvSpPr/>
-          <p:nvPr/>
-        </p:nvSpPr>
-        <p:spPr>
-          <a:xfrm>
-            <a:off x="1371600" y="3794760"/>
-            <a:ext cx="8686800" cy="548640"/>
-          </a:xfrm>
-          <a:prstGeom prst="rect">
-            <a:avLst/>
-          </a:prstGeom>
-          <a:noFill/>
-          <a:ln/>
-        </p:spPr>
-        <p:txBody>
-          <a:bodyPr wrap="square" rtlCol="0" anchor="ctr"/>
-          <a:lstStyle/>
-          <a:p>
-            <a:pPr indent="0" marL="0">
-              <a:buNone/>
-            </a:pPr>
-            <a:r>
-              <a:rPr lang="en-US" sz="1600" dirty="0">
-                <a:solidFill>
-                  <a:srgbClr val="E8F1EA"/>
-                </a:solidFill>
-                <a:latin typeface="Calibri" pitchFamily="34" charset="0"/>
-                <a:ea typeface="Calibri" pitchFamily="34" charset="-122"/>
-                <a:cs typeface="Calibri" pitchFamily="34" charset="-120"/>
-              </a:rPr>
-              <a:t>Chỉ nhân viên được cấp quyền mới sử dụng bot.</a:t>
-            </a:r>
-            <a:endParaRPr lang="en-US" sz="1600" dirty="0"/>
-          </a:p>
-        </p:txBody>
-      </p:sp>
-      <p:sp>
-        <p:nvSpPr>
-          <p:cNvPr id="15" name="Shape 13"/>
-          <p:cNvSpPr/>
-          <p:nvPr/>
-        </p:nvSpPr>
-        <p:spPr>
-          <a:xfrm>
-            <a:off x="640080" y="4572000"/>
-            <a:ext cx="502920" cy="502920"/>
-          </a:xfrm>
-          <a:prstGeom prst="ellipse">
-            <a:avLst/>
-          </a:prstGeom>
-          <a:solidFill>
-            <a:srgbClr val="E0A83B"/>
-          </a:solidFill>
-          <a:ln/>
-        </p:spPr>
-      </p:sp>
-      <p:sp>
-        <p:nvSpPr>
-          <p:cNvPr id="16" name="Text 14"/>
-          <p:cNvSpPr/>
-          <p:nvPr/>
-        </p:nvSpPr>
-        <p:spPr>
-          <a:xfrm>
-            <a:off x="640080" y="4572000"/>
-            <a:ext cx="502920" cy="502920"/>
-          </a:xfrm>
-          <a:prstGeom prst="rect">
-            <a:avLst/>
-          </a:prstGeom>
-          <a:noFill/>
-          <a:ln/>
-        </p:spPr>
-        <p:txBody>
-          <a:bodyPr wrap="square" rtlCol="0" anchor="ctr"/>
-          <a:lstStyle/>
-          <a:p>
-            <a:pPr algn="ctr" indent="0" marL="0">
-              <a:buNone/>
-            </a:pPr>
-            <a:r>
-              <a:rPr lang="en-US" sz="1800" b="1" dirty="0">
-                <a:solidFill>
-                  <a:srgbClr val="1B2A20"/>
-                </a:solidFill>
-                <a:latin typeface="Cambria" pitchFamily="34" charset="0"/>
-                <a:ea typeface="Cambria" pitchFamily="34" charset="-122"/>
-                <a:cs typeface="Cambria" pitchFamily="34" charset="-120"/>
-              </a:rPr>
-              <a:t>4</a:t>
-            </a:r>
-            <a:endParaRPr lang="en-US" sz="1800" dirty="0"/>
-          </a:p>
-        </p:txBody>
-      </p:sp>
-      <p:sp>
-        <p:nvSpPr>
-          <p:cNvPr id="17" name="Text 15"/>
-          <p:cNvSpPr/>
-          <p:nvPr/>
-        </p:nvSpPr>
-        <p:spPr>
-          <a:xfrm>
-            <a:off x="1371600" y="4572000"/>
-            <a:ext cx="8686800" cy="548640"/>
-          </a:xfrm>
-          <a:prstGeom prst="rect">
-            <a:avLst/>
-          </a:prstGeom>
-          <a:noFill/>
-          <a:ln/>
-        </p:spPr>
-        <p:txBody>
-          <a:bodyPr wrap="square" rtlCol="0" anchor="ctr"/>
-          <a:lstStyle/>
-          <a:p>
-            <a:pPr indent="0" marL="0">
-              <a:buNone/>
-            </a:pPr>
-            <a:r>
-              <a:rPr lang="en-US" sz="1600" dirty="0">
-                <a:solidFill>
-                  <a:srgbClr val="E8F1EA"/>
-                </a:solidFill>
-                <a:latin typeface="Calibri" pitchFamily="34" charset="0"/>
-                <a:ea typeface="Calibri" pitchFamily="34" charset="-122"/>
-                <a:cs typeface="Calibri" pitchFamily="34" charset="-120"/>
-              </a:rPr>
-              <a:t>Thấy sai sót thì báo quản lý, không tự ý sửa lung tung.</a:t>
-            </a:r>
-            <a:endParaRPr lang="en-US" sz="1600" dirty="0"/>
-          </a:p>
-        </p:txBody>
-      </p:sp>
-      <p:sp>
-        <p:nvSpPr>
-          <p:cNvPr id="18" name="Text 16"/>
-          <p:cNvSpPr/>
-          <p:nvPr/>
-        </p:nvSpPr>
-        <p:spPr>
-          <a:xfrm>
-            <a:off x="640080" y="5230368"/>
-            <a:ext cx="10908792" cy="320040"/>
-          </a:xfrm>
-          <a:prstGeom prst="rect">
-            <a:avLst/>
-          </a:prstGeom>
-          <a:noFill/>
-          <a:ln/>
-        </p:spPr>
-        <p:txBody>
-          <a:bodyPr wrap="square" rtlCol="0" anchor="ctr"/>
-          <a:lstStyle/>
-          <a:p>
-            <a:pPr algn="r" indent="0" marL="0">
-              <a:buNone/>
-            </a:pPr>
-            <a:r>
-              <a:rPr lang="en-US" sz="1300" dirty="0">
-                <a:solidFill>
-                  <a:srgbClr val="AFC3B4"/>
-                </a:solidFill>
-                <a:latin typeface="Calibri" pitchFamily="34" charset="0"/>
-                <a:ea typeface="Calibri" pitchFamily="34" charset="-122"/>
-                <a:cs typeface="Calibri" pitchFamily="34" charset="-120"/>
-              </a:rPr>
-              <a:t>Biên soạn &amp; triển khai:  </a:t>
-            </a:r>
-            <a:pPr algn="r" indent="0" marL="0">
-              <a:buNone/>
-            </a:pPr>
-            <a:r>
-              <a:rPr lang="en-US" sz="1300" b="1" dirty="0">
-                <a:solidFill>
-                  <a:srgbClr val="E0A83B"/>
-                </a:solidFill>
-                <a:latin typeface="Calibri" pitchFamily="34" charset="0"/>
-                <a:ea typeface="Calibri" pitchFamily="34" charset="-122"/>
-                <a:cs typeface="Calibri" pitchFamily="34" charset="-120"/>
-              </a:rPr>
-              <a:t>Phan Tấn Phương</a:t>
-            </a:r>
-            <a:endParaRPr lang="en-US" sz="1300" dirty="0"/>
-          </a:p>
-        </p:txBody>
-      </p:sp>
-      <p:sp>
-        <p:nvSpPr>
-          <p:cNvPr id="19" name="Shape 17"/>
-          <p:cNvSpPr/>
-          <p:nvPr/>
-        </p:nvSpPr>
-        <p:spPr>
-          <a:xfrm>
-            <a:off x="640080" y="5623560"/>
-            <a:ext cx="10908792" cy="777240"/>
+          <p:cNvPr id="4" name="Shape 2"/>
+          <p:cNvSpPr/>
+          <p:nvPr/>
+        </p:nvSpPr>
+        <p:spPr>
+          <a:xfrm>
+            <a:off x="9052560" y="640080"/>
+            <a:ext cx="2606040" cy="1783080"/>
           </a:xfrm>
           <a:prstGeom prst="roundRect">
             <a:avLst>
-              <a:gd name="adj" fmla="val 14118"/>
+              <a:gd name="adj" fmla="val 7179"/>
             </a:avLst>
           </a:prstGeom>
           <a:solidFill>
-            <a:srgbClr val="E0A83B"/>
+            <a:srgbClr val="F4EDDD"/>
           </a:solidFill>
           <a:ln/>
           <a:effectLst>
@@ -4539,9 +4048,585 @@
           </a:effectLst>
         </p:spPr>
       </p:sp>
-      <p:sp>
-        <p:nvSpPr>
-          <p:cNvPr id="20" name="Text 18"/>
+      <p:pic>
+        <p:nvPicPr>
+          <p:cNvPr id="5" name="Image 0" descr="/tmp/claude-0/-home-user-n8n/e6b51ae7-6c99-5683-8277-7db523f0061c/scratchpad/huongdan/company_logo.png">    </p:cNvPr>
+          <p:cNvPicPr>
+            <a:picLocks noChangeAspect="1"/>
+          </p:cNvPicPr>
+          <p:nvPr/>
+        </p:nvPicPr>
+        <p:blipFill>
+          <a:blip r:embed="rId1"/>
+          <a:stretch>
+            <a:fillRect/>
+          </a:stretch>
+        </p:blipFill>
+        <p:spPr>
+          <a:xfrm>
+            <a:off x="9189720" y="841248"/>
+            <a:ext cx="2331720" cy="1554480"/>
+          </a:xfrm>
+          <a:prstGeom prst="rect">
+            <a:avLst/>
+          </a:prstGeom>
+        </p:spPr>
+      </p:pic>
+      <p:sp>
+        <p:nvSpPr>
+          <p:cNvPr id="6" name="Text 3"/>
+          <p:cNvSpPr/>
+          <p:nvPr/>
+        </p:nvSpPr>
+        <p:spPr>
+          <a:xfrm>
+            <a:off x="640080" y="640080"/>
+            <a:ext cx="7680960" cy="548640"/>
+          </a:xfrm>
+          <a:prstGeom prst="rect">
+            <a:avLst/>
+          </a:prstGeom>
+          <a:noFill/>
+          <a:ln/>
+        </p:spPr>
+        <p:txBody>
+          <a:bodyPr wrap="square" rtlCol="0" anchor="ctr"/>
+          <a:lstStyle/>
+          <a:p>
+            <a:pPr indent="0" marL="0">
+              <a:buNone/>
+            </a:pPr>
+            <a:r>
+              <a:rPr lang="en-US" sz="1600" b="1" spc="200" kern="0" dirty="0">
+                <a:solidFill>
+                  <a:srgbClr val="D3AF2D"/>
+                </a:solidFill>
+                <a:latin typeface="Calibri" pitchFamily="34" charset="0"/>
+                <a:ea typeface="Calibri" pitchFamily="34" charset="-122"/>
+                <a:cs typeface="Calibri" pitchFamily="34" charset="-120"/>
+              </a:rPr>
+              <a:t>🔒  QUY TẮC VÀNG</a:t>
+            </a:r>
+            <a:endParaRPr lang="en-US" sz="1600" dirty="0"/>
+          </a:p>
+        </p:txBody>
+      </p:sp>
+      <p:sp>
+        <p:nvSpPr>
+          <p:cNvPr id="7" name="Text 4"/>
+          <p:cNvSpPr/>
+          <p:nvPr/>
+        </p:nvSpPr>
+        <p:spPr>
+          <a:xfrm>
+            <a:off x="640080" y="1143000"/>
+            <a:ext cx="7680960" cy="822960"/>
+          </a:xfrm>
+          <a:prstGeom prst="rect">
+            <a:avLst/>
+          </a:prstGeom>
+          <a:noFill/>
+          <a:ln/>
+        </p:spPr>
+        <p:txBody>
+          <a:bodyPr wrap="square" rtlCol="0" anchor="ctr"/>
+          <a:lstStyle/>
+          <a:p>
+            <a:pPr indent="0" marL="0">
+              <a:buNone/>
+            </a:pPr>
+            <a:r>
+              <a:rPr lang="en-US" sz="3600" b="1" dirty="0">
+                <a:solidFill>
+                  <a:srgbClr val="FFFFFF"/>
+                </a:solidFill>
+                <a:latin typeface="Cambria" pitchFamily="34" charset="0"/>
+                <a:ea typeface="Cambria" pitchFamily="34" charset="-122"/>
+                <a:cs typeface="Cambria" pitchFamily="34" charset="-120"/>
+              </a:rPr>
+              <a:t>Giữ an toàn cho dữ liệu</a:t>
+            </a:r>
+            <a:endParaRPr lang="en-US" sz="3600" dirty="0"/>
+          </a:p>
+        </p:txBody>
+      </p:sp>
+      <p:sp>
+        <p:nvSpPr>
+          <p:cNvPr id="8" name="Shape 5"/>
+          <p:cNvSpPr/>
+          <p:nvPr/>
+        </p:nvSpPr>
+        <p:spPr>
+          <a:xfrm>
+            <a:off x="640080" y="2240280"/>
+            <a:ext cx="502920" cy="502920"/>
+          </a:xfrm>
+          <a:prstGeom prst="ellipse">
+            <a:avLst/>
+          </a:prstGeom>
+          <a:solidFill>
+            <a:srgbClr val="D3AF2D"/>
+          </a:solidFill>
+          <a:ln/>
+        </p:spPr>
+      </p:sp>
+      <p:sp>
+        <p:nvSpPr>
+          <p:cNvPr id="9" name="Text 6"/>
+          <p:cNvSpPr/>
+          <p:nvPr/>
+        </p:nvSpPr>
+        <p:spPr>
+          <a:xfrm>
+            <a:off x="640080" y="2240280"/>
+            <a:ext cx="502920" cy="502920"/>
+          </a:xfrm>
+          <a:prstGeom prst="rect">
+            <a:avLst/>
+          </a:prstGeom>
+          <a:noFill/>
+          <a:ln/>
+        </p:spPr>
+        <p:txBody>
+          <a:bodyPr wrap="square" rtlCol="0" anchor="ctr"/>
+          <a:lstStyle/>
+          <a:p>
+            <a:pPr algn="ctr" indent="0" marL="0">
+              <a:buNone/>
+            </a:pPr>
+            <a:r>
+              <a:rPr lang="en-US" sz="1800" b="1" dirty="0">
+                <a:solidFill>
+                  <a:srgbClr val="1B2A20"/>
+                </a:solidFill>
+                <a:latin typeface="Cambria" pitchFamily="34" charset="0"/>
+                <a:ea typeface="Cambria" pitchFamily="34" charset="-122"/>
+                <a:cs typeface="Cambria" pitchFamily="34" charset="-120"/>
+              </a:rPr>
+              <a:t>1</a:t>
+            </a:r>
+            <a:endParaRPr lang="en-US" sz="1800" dirty="0"/>
+          </a:p>
+        </p:txBody>
+      </p:sp>
+      <p:sp>
+        <p:nvSpPr>
+          <p:cNvPr id="10" name="Text 7"/>
+          <p:cNvSpPr/>
+          <p:nvPr/>
+        </p:nvSpPr>
+        <p:spPr>
+          <a:xfrm>
+            <a:off x="1371600" y="2240280"/>
+            <a:ext cx="8686800" cy="548640"/>
+          </a:xfrm>
+          <a:prstGeom prst="rect">
+            <a:avLst/>
+          </a:prstGeom>
+          <a:noFill/>
+          <a:ln/>
+        </p:spPr>
+        <p:txBody>
+          <a:bodyPr wrap="square" rtlCol="0" anchor="ctr"/>
+          <a:lstStyle/>
+          <a:p>
+            <a:pPr indent="0" marL="0">
+              <a:buNone/>
+            </a:pPr>
+            <a:r>
+              <a:rPr lang="en-US" sz="1600" dirty="0">
+                <a:solidFill>
+                  <a:srgbClr val="E8F1EA"/>
+                </a:solidFill>
+                <a:latin typeface="Calibri" pitchFamily="34" charset="0"/>
+                <a:ea typeface="Calibri" pitchFamily="34" charset="-122"/>
+                <a:cs typeface="Calibri" pitchFamily="34" charset="-120"/>
+              </a:rPr>
+              <a:t>Không chia sẻ đường link bot cho người ngoài công ty.</a:t>
+            </a:r>
+            <a:endParaRPr lang="en-US" sz="1600" dirty="0"/>
+          </a:p>
+        </p:txBody>
+      </p:sp>
+      <p:sp>
+        <p:nvSpPr>
+          <p:cNvPr id="11" name="Shape 8"/>
+          <p:cNvSpPr/>
+          <p:nvPr/>
+        </p:nvSpPr>
+        <p:spPr>
+          <a:xfrm>
+            <a:off x="640080" y="3017520"/>
+            <a:ext cx="502920" cy="502920"/>
+          </a:xfrm>
+          <a:prstGeom prst="ellipse">
+            <a:avLst/>
+          </a:prstGeom>
+          <a:solidFill>
+            <a:srgbClr val="D3AF2D"/>
+          </a:solidFill>
+          <a:ln/>
+        </p:spPr>
+      </p:sp>
+      <p:sp>
+        <p:nvSpPr>
+          <p:cNvPr id="12" name="Text 9"/>
+          <p:cNvSpPr/>
+          <p:nvPr/>
+        </p:nvSpPr>
+        <p:spPr>
+          <a:xfrm>
+            <a:off x="640080" y="3017520"/>
+            <a:ext cx="502920" cy="502920"/>
+          </a:xfrm>
+          <a:prstGeom prst="rect">
+            <a:avLst/>
+          </a:prstGeom>
+          <a:noFill/>
+          <a:ln/>
+        </p:spPr>
+        <p:txBody>
+          <a:bodyPr wrap="square" rtlCol="0" anchor="ctr"/>
+          <a:lstStyle/>
+          <a:p>
+            <a:pPr algn="ctr" indent="0" marL="0">
+              <a:buNone/>
+            </a:pPr>
+            <a:r>
+              <a:rPr lang="en-US" sz="1800" b="1" dirty="0">
+                <a:solidFill>
+                  <a:srgbClr val="1B2A20"/>
+                </a:solidFill>
+                <a:latin typeface="Cambria" pitchFamily="34" charset="0"/>
+                <a:ea typeface="Cambria" pitchFamily="34" charset="-122"/>
+                <a:cs typeface="Cambria" pitchFamily="34" charset="-120"/>
+              </a:rPr>
+              <a:t>2</a:t>
+            </a:r>
+            <a:endParaRPr lang="en-US" sz="1800" dirty="0"/>
+          </a:p>
+        </p:txBody>
+      </p:sp>
+      <p:sp>
+        <p:nvSpPr>
+          <p:cNvPr id="13" name="Text 10"/>
+          <p:cNvSpPr/>
+          <p:nvPr/>
+        </p:nvSpPr>
+        <p:spPr>
+          <a:xfrm>
+            <a:off x="1371600" y="3017520"/>
+            <a:ext cx="8686800" cy="548640"/>
+          </a:xfrm>
+          <a:prstGeom prst="rect">
+            <a:avLst/>
+          </a:prstGeom>
+          <a:noFill/>
+          <a:ln/>
+        </p:spPr>
+        <p:txBody>
+          <a:bodyPr wrap="square" rtlCol="0" anchor="ctr"/>
+          <a:lstStyle/>
+          <a:p>
+            <a:pPr indent="0" marL="0">
+              <a:buNone/>
+            </a:pPr>
+            <a:r>
+              <a:rPr lang="en-US" sz="1600" dirty="0">
+                <a:solidFill>
+                  <a:srgbClr val="E8F1EA"/>
+                </a:solidFill>
+                <a:latin typeface="Calibri" pitchFamily="34" charset="0"/>
+                <a:ea typeface="Calibri" pitchFamily="34" charset="-122"/>
+                <a:cs typeface="Calibri" pitchFamily="34" charset="-120"/>
+              </a:rPr>
+              <a:t>Không dùng ảnh căn cước cho mục đích ngoài công việc.</a:t>
+            </a:r>
+            <a:endParaRPr lang="en-US" sz="1600" dirty="0"/>
+          </a:p>
+        </p:txBody>
+      </p:sp>
+      <p:sp>
+        <p:nvSpPr>
+          <p:cNvPr id="14" name="Shape 11"/>
+          <p:cNvSpPr/>
+          <p:nvPr/>
+        </p:nvSpPr>
+        <p:spPr>
+          <a:xfrm>
+            <a:off x="640080" y="3794760"/>
+            <a:ext cx="502920" cy="502920"/>
+          </a:xfrm>
+          <a:prstGeom prst="ellipse">
+            <a:avLst/>
+          </a:prstGeom>
+          <a:solidFill>
+            <a:srgbClr val="D3AF2D"/>
+          </a:solidFill>
+          <a:ln/>
+        </p:spPr>
+      </p:sp>
+      <p:sp>
+        <p:nvSpPr>
+          <p:cNvPr id="15" name="Text 12"/>
+          <p:cNvSpPr/>
+          <p:nvPr/>
+        </p:nvSpPr>
+        <p:spPr>
+          <a:xfrm>
+            <a:off x="640080" y="3794760"/>
+            <a:ext cx="502920" cy="502920"/>
+          </a:xfrm>
+          <a:prstGeom prst="rect">
+            <a:avLst/>
+          </a:prstGeom>
+          <a:noFill/>
+          <a:ln/>
+        </p:spPr>
+        <p:txBody>
+          <a:bodyPr wrap="square" rtlCol="0" anchor="ctr"/>
+          <a:lstStyle/>
+          <a:p>
+            <a:pPr algn="ctr" indent="0" marL="0">
+              <a:buNone/>
+            </a:pPr>
+            <a:r>
+              <a:rPr lang="en-US" sz="1800" b="1" dirty="0">
+                <a:solidFill>
+                  <a:srgbClr val="1B2A20"/>
+                </a:solidFill>
+                <a:latin typeface="Cambria" pitchFamily="34" charset="0"/>
+                <a:ea typeface="Cambria" pitchFamily="34" charset="-122"/>
+                <a:cs typeface="Cambria" pitchFamily="34" charset="-120"/>
+              </a:rPr>
+              <a:t>3</a:t>
+            </a:r>
+            <a:endParaRPr lang="en-US" sz="1800" dirty="0"/>
+          </a:p>
+        </p:txBody>
+      </p:sp>
+      <p:sp>
+        <p:nvSpPr>
+          <p:cNvPr id="16" name="Text 13"/>
+          <p:cNvSpPr/>
+          <p:nvPr/>
+        </p:nvSpPr>
+        <p:spPr>
+          <a:xfrm>
+            <a:off x="1371600" y="3794760"/>
+            <a:ext cx="8686800" cy="548640"/>
+          </a:xfrm>
+          <a:prstGeom prst="rect">
+            <a:avLst/>
+          </a:prstGeom>
+          <a:noFill/>
+          <a:ln/>
+        </p:spPr>
+        <p:txBody>
+          <a:bodyPr wrap="square" rtlCol="0" anchor="ctr"/>
+          <a:lstStyle/>
+          <a:p>
+            <a:pPr indent="0" marL="0">
+              <a:buNone/>
+            </a:pPr>
+            <a:r>
+              <a:rPr lang="en-US" sz="1600" dirty="0">
+                <a:solidFill>
+                  <a:srgbClr val="E8F1EA"/>
+                </a:solidFill>
+                <a:latin typeface="Calibri" pitchFamily="34" charset="0"/>
+                <a:ea typeface="Calibri" pitchFamily="34" charset="-122"/>
+                <a:cs typeface="Calibri" pitchFamily="34" charset="-120"/>
+              </a:rPr>
+              <a:t>Chỉ nhân viên được cấp quyền mới sử dụng bot.</a:t>
+            </a:r>
+            <a:endParaRPr lang="en-US" sz="1600" dirty="0"/>
+          </a:p>
+        </p:txBody>
+      </p:sp>
+      <p:sp>
+        <p:nvSpPr>
+          <p:cNvPr id="17" name="Shape 14"/>
+          <p:cNvSpPr/>
+          <p:nvPr/>
+        </p:nvSpPr>
+        <p:spPr>
+          <a:xfrm>
+            <a:off x="640080" y="4572000"/>
+            <a:ext cx="502920" cy="502920"/>
+          </a:xfrm>
+          <a:prstGeom prst="ellipse">
+            <a:avLst/>
+          </a:prstGeom>
+          <a:solidFill>
+            <a:srgbClr val="D3AF2D"/>
+          </a:solidFill>
+          <a:ln/>
+        </p:spPr>
+      </p:sp>
+      <p:sp>
+        <p:nvSpPr>
+          <p:cNvPr id="18" name="Text 15"/>
+          <p:cNvSpPr/>
+          <p:nvPr/>
+        </p:nvSpPr>
+        <p:spPr>
+          <a:xfrm>
+            <a:off x="640080" y="4572000"/>
+            <a:ext cx="502920" cy="502920"/>
+          </a:xfrm>
+          <a:prstGeom prst="rect">
+            <a:avLst/>
+          </a:prstGeom>
+          <a:noFill/>
+          <a:ln/>
+        </p:spPr>
+        <p:txBody>
+          <a:bodyPr wrap="square" rtlCol="0" anchor="ctr"/>
+          <a:lstStyle/>
+          <a:p>
+            <a:pPr algn="ctr" indent="0" marL="0">
+              <a:buNone/>
+            </a:pPr>
+            <a:r>
+              <a:rPr lang="en-US" sz="1800" b="1" dirty="0">
+                <a:solidFill>
+                  <a:srgbClr val="1B2A20"/>
+                </a:solidFill>
+                <a:latin typeface="Cambria" pitchFamily="34" charset="0"/>
+                <a:ea typeface="Cambria" pitchFamily="34" charset="-122"/>
+                <a:cs typeface="Cambria" pitchFamily="34" charset="-120"/>
+              </a:rPr>
+              <a:t>4</a:t>
+            </a:r>
+            <a:endParaRPr lang="en-US" sz="1800" dirty="0"/>
+          </a:p>
+        </p:txBody>
+      </p:sp>
+      <p:sp>
+        <p:nvSpPr>
+          <p:cNvPr id="19" name="Text 16"/>
+          <p:cNvSpPr/>
+          <p:nvPr/>
+        </p:nvSpPr>
+        <p:spPr>
+          <a:xfrm>
+            <a:off x="1371600" y="4572000"/>
+            <a:ext cx="8686800" cy="548640"/>
+          </a:xfrm>
+          <a:prstGeom prst="rect">
+            <a:avLst/>
+          </a:prstGeom>
+          <a:noFill/>
+          <a:ln/>
+        </p:spPr>
+        <p:txBody>
+          <a:bodyPr wrap="square" rtlCol="0" anchor="ctr"/>
+          <a:lstStyle/>
+          <a:p>
+            <a:pPr indent="0" marL="0">
+              <a:buNone/>
+            </a:pPr>
+            <a:r>
+              <a:rPr lang="en-US" sz="1600" dirty="0">
+                <a:solidFill>
+                  <a:srgbClr val="E8F1EA"/>
+                </a:solidFill>
+                <a:latin typeface="Calibri" pitchFamily="34" charset="0"/>
+                <a:ea typeface="Calibri" pitchFamily="34" charset="-122"/>
+                <a:cs typeface="Calibri" pitchFamily="34" charset="-120"/>
+              </a:rPr>
+              <a:t>Thấy sai sót thì báo quản lý, không tự ý sửa lung tung.</a:t>
+            </a:r>
+            <a:endParaRPr lang="en-US" sz="1600" dirty="0"/>
+          </a:p>
+        </p:txBody>
+      </p:sp>
+      <p:sp>
+        <p:nvSpPr>
+          <p:cNvPr id="20" name="Text 17"/>
+          <p:cNvSpPr/>
+          <p:nvPr/>
+        </p:nvSpPr>
+        <p:spPr>
+          <a:xfrm>
+            <a:off x="640080" y="5230368"/>
+            <a:ext cx="10908792" cy="320040"/>
+          </a:xfrm>
+          <a:prstGeom prst="rect">
+            <a:avLst/>
+          </a:prstGeom>
+          <a:noFill/>
+          <a:ln/>
+        </p:spPr>
+        <p:txBody>
+          <a:bodyPr wrap="square" rtlCol="0" anchor="ctr"/>
+          <a:lstStyle/>
+          <a:p>
+            <a:pPr algn="r" indent="0" marL="0">
+              <a:buNone/>
+            </a:pPr>
+            <a:r>
+              <a:rPr lang="en-US" sz="1300" dirty="0">
+                <a:solidFill>
+                  <a:srgbClr val="AFC3B4"/>
+                </a:solidFill>
+                <a:latin typeface="Calibri" pitchFamily="34" charset="0"/>
+                <a:ea typeface="Calibri" pitchFamily="34" charset="-122"/>
+                <a:cs typeface="Calibri" pitchFamily="34" charset="-120"/>
+              </a:rPr>
+              <a:t>Biên soạn &amp; triển khai:  </a:t>
+            </a:r>
+            <a:pPr algn="r" indent="0" marL="0">
+              <a:buNone/>
+            </a:pPr>
+            <a:r>
+              <a:rPr lang="en-US" sz="1300" b="1" dirty="0">
+                <a:solidFill>
+                  <a:srgbClr val="D3AF2D"/>
+                </a:solidFill>
+                <a:latin typeface="Calibri" pitchFamily="34" charset="0"/>
+                <a:ea typeface="Calibri" pitchFamily="34" charset="-122"/>
+                <a:cs typeface="Calibri" pitchFamily="34" charset="-120"/>
+              </a:rPr>
+              <a:t>Phan Tấn Phương</a:t>
+            </a:r>
+            <a:endParaRPr lang="en-US" sz="1300" dirty="0"/>
+          </a:p>
+        </p:txBody>
+      </p:sp>
+      <p:sp>
+        <p:nvSpPr>
+          <p:cNvPr id="21" name="Shape 18"/>
+          <p:cNvSpPr/>
+          <p:nvPr/>
+        </p:nvSpPr>
+        <p:spPr>
+          <a:xfrm>
+            <a:off x="640080" y="5623560"/>
+            <a:ext cx="10908792" cy="777240"/>
+          </a:xfrm>
+          <a:prstGeom prst="roundRect">
+            <a:avLst>
+              <a:gd name="adj" fmla="val 14118"/>
+            </a:avLst>
+          </a:prstGeom>
+          <a:solidFill>
+            <a:srgbClr val="D3AF2D"/>
+          </a:solidFill>
+          <a:ln/>
+          <a:effectLst>
+            <a:outerShdw sx="100000" sy="100000" kx="0" ky="0" algn="bl" rotWithShape="0" blurRad="114300" dist="38100" dir="5400000">
+              <a:srgbClr val="8AA090">
+                <a:alpha val="35000"/>
+              </a:srgbClr>
+            </a:outerShdw>
+          </a:effectLst>
+        </p:spPr>
+      </p:sp>
+      <p:sp>
+        <p:nvSpPr>
+          <p:cNvPr id="22" name="Text 19"/>
           <p:cNvSpPr/>
           <p:nvPr/>
         </p:nvSpPr>
@@ -4637,7 +4722,7 @@
             <a:r>
               <a:rPr lang="en-US" sz="1300" b="1" spc="200" kern="0" dirty="0">
                 <a:solidFill>
-                  <a:srgbClr val="B9832B"/>
+                  <a:srgbClr val="9C7714"/>
                 </a:solidFill>
                 <a:latin typeface="Calibri" pitchFamily="34" charset="0"/>
                 <a:ea typeface="Calibri" pitchFamily="34" charset="-122"/>
@@ -4676,7 +4761,7 @@
             <a:r>
               <a:rPr lang="en-US" sz="3400" b="1" dirty="0">
                 <a:solidFill>
-                  <a:srgbClr val="1E4D2B"/>
+                  <a:srgbClr val="15451F"/>
                 </a:solidFill>
                 <a:latin typeface="Cambria" pitchFamily="34" charset="0"/>
                 <a:ea typeface="Cambria" pitchFamily="34" charset="-122"/>
@@ -4718,7 +4803,7 @@
             <a:r>
               <a:rPr lang="en-US" sz="1500" dirty="0">
                 <a:solidFill>
-                  <a:srgbClr val="5E6B60"/>
+                  <a:srgbClr val="55635A"/>
                 </a:solidFill>
                 <a:latin typeface="Calibri" pitchFamily="34" charset="0"/>
                 <a:ea typeface="Calibri" pitchFamily="34" charset="-122"/>
@@ -4738,7 +4823,7 @@
             <a:r>
               <a:rPr lang="en-US" sz="1500" dirty="0">
                 <a:solidFill>
-                  <a:srgbClr val="5E6B60"/>
+                  <a:srgbClr val="55635A"/>
                 </a:solidFill>
                 <a:latin typeface="Calibri" pitchFamily="34" charset="0"/>
                 <a:ea typeface="Calibri" pitchFamily="34" charset="-122"/>
@@ -4767,7 +4852,7 @@
             </a:avLst>
           </a:prstGeom>
           <a:solidFill>
-            <a:srgbClr val="EFF4EE"/>
+            <a:srgbClr val="EDF3ED"/>
           </a:solidFill>
           <a:ln/>
           <a:effectLst>
@@ -4794,7 +4879,7 @@
             <a:avLst/>
           </a:prstGeom>
           <a:solidFill>
-            <a:srgbClr val="1E4D2B"/>
+            <a:srgbClr val="15451F"/>
           </a:solidFill>
           <a:ln/>
         </p:spPr>
@@ -4865,7 +4950,7 @@
             <a:r>
               <a:rPr lang="en-US" sz="1900" b="1" dirty="0">
                 <a:solidFill>
-                  <a:srgbClr val="1E4D2B"/>
+                  <a:srgbClr val="15451F"/>
                 </a:solidFill>
                 <a:latin typeface="Cambria" pitchFamily="34" charset="0"/>
                 <a:ea typeface="Cambria" pitchFamily="34" charset="-122"/>
@@ -4907,7 +4992,7 @@
             <a:r>
               <a:rPr lang="en-US" sz="1250" dirty="0">
                 <a:solidFill>
-                  <a:srgbClr val="5E6B60"/>
+                  <a:srgbClr val="55635A"/>
                 </a:solidFill>
                 <a:latin typeface="Calibri" pitchFamily="34" charset="0"/>
                 <a:ea typeface="Calibri" pitchFamily="34" charset="-122"/>
@@ -4936,7 +5021,7 @@
             </a:avLst>
           </a:prstGeom>
           <a:solidFill>
-            <a:srgbClr val="EFF4EE"/>
+            <a:srgbClr val="EDF3ED"/>
           </a:solidFill>
           <a:ln/>
           <a:effectLst>
@@ -4963,7 +5048,7 @@
             <a:avLst/>
           </a:prstGeom>
           <a:solidFill>
-            <a:srgbClr val="1E4D2B"/>
+            <a:srgbClr val="15451F"/>
           </a:solidFill>
           <a:ln/>
         </p:spPr>
@@ -5034,7 +5119,7 @@
             <a:r>
               <a:rPr lang="en-US" sz="1900" b="1" dirty="0">
                 <a:solidFill>
-                  <a:srgbClr val="1E4D2B"/>
+                  <a:srgbClr val="15451F"/>
                 </a:solidFill>
                 <a:latin typeface="Cambria" pitchFamily="34" charset="0"/>
                 <a:ea typeface="Cambria" pitchFamily="34" charset="-122"/>
@@ -5076,7 +5161,7 @@
             <a:r>
               <a:rPr lang="en-US" sz="1250" dirty="0">
                 <a:solidFill>
-                  <a:srgbClr val="5E6B60"/>
+                  <a:srgbClr val="55635A"/>
                 </a:solidFill>
                 <a:latin typeface="Calibri" pitchFamily="34" charset="0"/>
                 <a:ea typeface="Calibri" pitchFamily="34" charset="-122"/>
@@ -5105,7 +5190,7 @@
             </a:avLst>
           </a:prstGeom>
           <a:solidFill>
-            <a:srgbClr val="EFF4EE"/>
+            <a:srgbClr val="EDF3ED"/>
           </a:solidFill>
           <a:ln/>
           <a:effectLst>
@@ -5132,7 +5217,7 @@
             <a:avLst/>
           </a:prstGeom>
           <a:solidFill>
-            <a:srgbClr val="1E4D2B"/>
+            <a:srgbClr val="15451F"/>
           </a:solidFill>
           <a:ln/>
         </p:spPr>
@@ -5203,7 +5288,7 @@
             <a:r>
               <a:rPr lang="en-US" sz="1900" b="1" dirty="0">
                 <a:solidFill>
-                  <a:srgbClr val="1E4D2B"/>
+                  <a:srgbClr val="15451F"/>
                 </a:solidFill>
                 <a:latin typeface="Cambria" pitchFamily="34" charset="0"/>
                 <a:ea typeface="Cambria" pitchFamily="34" charset="-122"/>
@@ -5245,7 +5330,7 @@
             <a:r>
               <a:rPr lang="en-US" sz="1250" dirty="0">
                 <a:solidFill>
-                  <a:srgbClr val="5E6B60"/>
+                  <a:srgbClr val="55635A"/>
                 </a:solidFill>
                 <a:latin typeface="Calibri" pitchFamily="34" charset="0"/>
                 <a:ea typeface="Calibri" pitchFamily="34" charset="-122"/>
@@ -5274,7 +5359,7 @@
             </a:avLst>
           </a:prstGeom>
           <a:solidFill>
-            <a:srgbClr val="EFF4EE"/>
+            <a:srgbClr val="EDF3ED"/>
           </a:solidFill>
           <a:ln/>
           <a:effectLst>
@@ -5301,7 +5386,7 @@
             <a:avLst/>
           </a:prstGeom>
           <a:solidFill>
-            <a:srgbClr val="1E4D2B"/>
+            <a:srgbClr val="15451F"/>
           </a:solidFill>
           <a:ln/>
         </p:spPr>
@@ -5372,7 +5457,7 @@
             <a:r>
               <a:rPr lang="en-US" sz="1900" b="1" dirty="0">
                 <a:solidFill>
-                  <a:srgbClr val="1E4D2B"/>
+                  <a:srgbClr val="15451F"/>
                 </a:solidFill>
                 <a:latin typeface="Cambria" pitchFamily="34" charset="0"/>
                 <a:ea typeface="Cambria" pitchFamily="34" charset="-122"/>
@@ -5414,7 +5499,7 @@
             <a:r>
               <a:rPr lang="en-US" sz="1250" dirty="0">
                 <a:solidFill>
-                  <a:srgbClr val="5E6B60"/>
+                  <a:srgbClr val="55635A"/>
                 </a:solidFill>
                 <a:latin typeface="Calibri" pitchFamily="34" charset="0"/>
                 <a:ea typeface="Calibri" pitchFamily="34" charset="-122"/>
@@ -5453,7 +5538,7 @@
             <a:r>
               <a:rPr lang="en-US" sz="900" dirty="0">
                 <a:solidFill>
-                  <a:srgbClr val="5E6B60"/>
+                  <a:srgbClr val="55635A"/>
                 </a:solidFill>
                 <a:latin typeface="Calibri" pitchFamily="34" charset="0"/>
                 <a:ea typeface="Calibri" pitchFamily="34" charset="-122"/>
@@ -5506,7 +5591,7 @@
             <a:r>
               <a:rPr lang="en-US" sz="1000" dirty="0">
                 <a:solidFill>
-                  <a:srgbClr val="5E6B60"/>
+                  <a:srgbClr val="55635A"/>
                 </a:solidFill>
                 <a:latin typeface="Calibri" pitchFamily="34" charset="0"/>
                 <a:ea typeface="Calibri" pitchFamily="34" charset="-122"/>
@@ -5577,7 +5662,7 @@
             <a:r>
               <a:rPr lang="en-US" sz="1300" b="1" spc="200" kern="0" dirty="0">
                 <a:solidFill>
-                  <a:srgbClr val="B9832B"/>
+                  <a:srgbClr val="9C7714"/>
                 </a:solidFill>
                 <a:latin typeface="Calibri" pitchFamily="34" charset="0"/>
                 <a:ea typeface="Calibri" pitchFamily="34" charset="-122"/>
@@ -5616,7 +5701,7 @@
             <a:r>
               <a:rPr lang="en-US" sz="3400" b="1" dirty="0">
                 <a:solidFill>
-                  <a:srgbClr val="1E4D2B"/>
+                  <a:srgbClr val="15451F"/>
                 </a:solidFill>
                 <a:latin typeface="Cambria" pitchFamily="34" charset="0"/>
                 <a:ea typeface="Cambria" pitchFamily="34" charset="-122"/>
@@ -5645,7 +5730,7 @@
             </a:avLst>
           </a:prstGeom>
           <a:solidFill>
-            <a:srgbClr val="EFF4EE"/>
+            <a:srgbClr val="EDF3ED"/>
           </a:solidFill>
           <a:ln/>
           <a:effectLst>
@@ -5672,7 +5757,7 @@
             <a:avLst/>
           </a:prstGeom>
           <a:solidFill>
-            <a:srgbClr val="E0A83B"/>
+            <a:srgbClr val="D3AF2D"/>
           </a:solidFill>
           <a:ln/>
         </p:spPr>
@@ -5743,7 +5828,7 @@
             <a:r>
               <a:rPr lang="en-US" sz="2000" b="1" dirty="0">
                 <a:solidFill>
-                  <a:srgbClr val="1E4D2B"/>
+                  <a:srgbClr val="15451F"/>
                 </a:solidFill>
                 <a:latin typeface="Cambria" pitchFamily="34" charset="0"/>
                 <a:ea typeface="Cambria" pitchFamily="34" charset="-122"/>
@@ -5785,7 +5870,7 @@
             <a:r>
               <a:rPr lang="en-US" sz="1350" dirty="0">
                 <a:solidFill>
-                  <a:srgbClr val="5E6B60"/>
+                  <a:srgbClr val="55635A"/>
                 </a:solidFill>
                 <a:latin typeface="Calibri" pitchFamily="34" charset="0"/>
                 <a:ea typeface="Calibri" pitchFamily="34" charset="-122"/>
@@ -5824,7 +5909,7 @@
             <a:r>
               <a:rPr lang="en-US" sz="2800" b="1" dirty="0">
                 <a:solidFill>
-                  <a:srgbClr val="6FA86A"/>
+                  <a:srgbClr val="4E8C55"/>
                 </a:solidFill>
                 <a:latin typeface="Calibri" pitchFamily="34" charset="0"/>
                 <a:ea typeface="Calibri" pitchFamily="34" charset="-122"/>
@@ -5853,7 +5938,7 @@
             </a:avLst>
           </a:prstGeom>
           <a:solidFill>
-            <a:srgbClr val="EFF4EE"/>
+            <a:srgbClr val="EDF3ED"/>
           </a:solidFill>
           <a:ln/>
           <a:effectLst>
@@ -5880,7 +5965,7 @@
             <a:avLst/>
           </a:prstGeom>
           <a:solidFill>
-            <a:srgbClr val="E0A83B"/>
+            <a:srgbClr val="D3AF2D"/>
           </a:solidFill>
           <a:ln/>
         </p:spPr>
@@ -5951,7 +6036,7 @@
             <a:r>
               <a:rPr lang="en-US" sz="2000" b="1" dirty="0">
                 <a:solidFill>
-                  <a:srgbClr val="1E4D2B"/>
+                  <a:srgbClr val="15451F"/>
                 </a:solidFill>
                 <a:latin typeface="Cambria" pitchFamily="34" charset="0"/>
                 <a:ea typeface="Cambria" pitchFamily="34" charset="-122"/>
@@ -5993,7 +6078,7 @@
             <a:r>
               <a:rPr lang="en-US" sz="1350" dirty="0">
                 <a:solidFill>
-                  <a:srgbClr val="5E6B60"/>
+                  <a:srgbClr val="55635A"/>
                 </a:solidFill>
                 <a:latin typeface="Calibri" pitchFamily="34" charset="0"/>
                 <a:ea typeface="Calibri" pitchFamily="34" charset="-122"/>
@@ -6032,7 +6117,7 @@
             <a:r>
               <a:rPr lang="en-US" sz="2800" b="1" dirty="0">
                 <a:solidFill>
-                  <a:srgbClr val="6FA86A"/>
+                  <a:srgbClr val="4E8C55"/>
                 </a:solidFill>
                 <a:latin typeface="Calibri" pitchFamily="34" charset="0"/>
                 <a:ea typeface="Calibri" pitchFamily="34" charset="-122"/>
@@ -6061,7 +6146,7 @@
             </a:avLst>
           </a:prstGeom>
           <a:solidFill>
-            <a:srgbClr val="EFF4EE"/>
+            <a:srgbClr val="EDF3ED"/>
           </a:solidFill>
           <a:ln/>
           <a:effectLst>
@@ -6088,7 +6173,7 @@
             <a:avLst/>
           </a:prstGeom>
           <a:solidFill>
-            <a:srgbClr val="E0A83B"/>
+            <a:srgbClr val="D3AF2D"/>
           </a:solidFill>
           <a:ln/>
         </p:spPr>
@@ -6159,7 +6244,7 @@
             <a:r>
               <a:rPr lang="en-US" sz="2000" b="1" dirty="0">
                 <a:solidFill>
-                  <a:srgbClr val="1E4D2B"/>
+                  <a:srgbClr val="15451F"/>
                 </a:solidFill>
                 <a:latin typeface="Cambria" pitchFamily="34" charset="0"/>
                 <a:ea typeface="Cambria" pitchFamily="34" charset="-122"/>
@@ -6201,7 +6286,7 @@
             <a:r>
               <a:rPr lang="en-US" sz="1350" dirty="0">
                 <a:solidFill>
-                  <a:srgbClr val="5E6B60"/>
+                  <a:srgbClr val="55635A"/>
                 </a:solidFill>
                 <a:latin typeface="Calibri" pitchFamily="34" charset="0"/>
                 <a:ea typeface="Calibri" pitchFamily="34" charset="-122"/>
@@ -6240,7 +6325,7 @@
             <a:r>
               <a:rPr lang="en-US" sz="1350" i="1" dirty="0">
                 <a:solidFill>
-                  <a:srgbClr val="B9832B"/>
+                  <a:srgbClr val="9C7714"/>
                 </a:solidFill>
                 <a:latin typeface="Calibri" pitchFamily="34" charset="0"/>
                 <a:ea typeface="Calibri" pitchFamily="34" charset="-122"/>
@@ -6279,7 +6364,7 @@
             <a:r>
               <a:rPr lang="en-US" sz="900" dirty="0">
                 <a:solidFill>
-                  <a:srgbClr val="5E6B60"/>
+                  <a:srgbClr val="55635A"/>
                 </a:solidFill>
                 <a:latin typeface="Calibri" pitchFamily="34" charset="0"/>
                 <a:ea typeface="Calibri" pitchFamily="34" charset="-122"/>
@@ -6332,7 +6417,7 @@
             <a:r>
               <a:rPr lang="en-US" sz="1000" dirty="0">
                 <a:solidFill>
-                  <a:srgbClr val="5E6B60"/>
+                  <a:srgbClr val="55635A"/>
                 </a:solidFill>
                 <a:latin typeface="Calibri" pitchFamily="34" charset="0"/>
                 <a:ea typeface="Calibri" pitchFamily="34" charset="-122"/>
@@ -6403,7 +6488,7 @@
             <a:r>
               <a:rPr lang="en-US" sz="1300" b="1" spc="200" kern="0" dirty="0">
                 <a:solidFill>
-                  <a:srgbClr val="B9832B"/>
+                  <a:srgbClr val="9C7714"/>
                 </a:solidFill>
                 <a:latin typeface="Calibri" pitchFamily="34" charset="0"/>
                 <a:ea typeface="Calibri" pitchFamily="34" charset="-122"/>
@@ -6442,7 +6527,7 @@
             <a:r>
               <a:rPr lang="en-US" sz="3400" b="1" dirty="0">
                 <a:solidFill>
-                  <a:srgbClr val="1E4D2B"/>
+                  <a:srgbClr val="15451F"/>
                 </a:solidFill>
                 <a:latin typeface="Cambria" pitchFamily="34" charset="0"/>
                 <a:ea typeface="Cambria" pitchFamily="34" charset="-122"/>
@@ -6484,7 +6569,7 @@
             <a:r>
               <a:rPr lang="en-US" sz="1450" dirty="0">
                 <a:solidFill>
-                  <a:srgbClr val="5E6B60"/>
+                  <a:srgbClr val="55635A"/>
                 </a:solidFill>
                 <a:latin typeface="Calibri" pitchFamily="34" charset="0"/>
                 <a:ea typeface="Calibri" pitchFamily="34" charset="-122"/>
@@ -6513,7 +6598,7 @@
             </a:avLst>
           </a:prstGeom>
           <a:solidFill>
-            <a:srgbClr val="EFF4EE"/>
+            <a:srgbClr val="EDF3ED"/>
           </a:solidFill>
           <a:ln/>
           <a:effectLst>
@@ -6540,7 +6625,7 @@
             <a:avLst/>
           </a:prstGeom>
           <a:solidFill>
-            <a:srgbClr val="1E4D2B"/>
+            <a:srgbClr val="15451F"/>
           </a:solidFill>
           <a:ln/>
         </p:spPr>
@@ -6611,7 +6696,7 @@
             <a:r>
               <a:rPr lang="en-US" sz="2100" b="1" dirty="0">
                 <a:solidFill>
-                  <a:srgbClr val="1E4D2B"/>
+                  <a:srgbClr val="15451F"/>
                 </a:solidFill>
                 <a:latin typeface="Cambria" pitchFamily="34" charset="0"/>
                 <a:ea typeface="Cambria" pitchFamily="34" charset="-122"/>
@@ -6653,7 +6738,7 @@
             <a:r>
               <a:rPr lang="en-US" sz="1300" dirty="0">
                 <a:solidFill>
-                  <a:srgbClr val="5E6B60"/>
+                  <a:srgbClr val="55635A"/>
                 </a:solidFill>
                 <a:latin typeface="Calibri" pitchFamily="34" charset="0"/>
                 <a:ea typeface="Calibri" pitchFamily="34" charset="-122"/>
@@ -6682,7 +6767,7 @@
             </a:avLst>
           </a:prstGeom>
           <a:solidFill>
-            <a:srgbClr val="EFF4EE"/>
+            <a:srgbClr val="EDF3ED"/>
           </a:solidFill>
           <a:ln/>
           <a:effectLst>
@@ -6709,7 +6794,7 @@
             <a:avLst/>
           </a:prstGeom>
           <a:solidFill>
-            <a:srgbClr val="2E7D46"/>
+            <a:srgbClr val="236B30"/>
           </a:solidFill>
           <a:ln/>
         </p:spPr>
@@ -6780,7 +6865,7 @@
             <a:r>
               <a:rPr lang="en-US" sz="2100" b="1" dirty="0">
                 <a:solidFill>
-                  <a:srgbClr val="1E4D2B"/>
+                  <a:srgbClr val="15451F"/>
                 </a:solidFill>
                 <a:latin typeface="Cambria" pitchFamily="34" charset="0"/>
                 <a:ea typeface="Cambria" pitchFamily="34" charset="-122"/>
@@ -6822,7 +6907,7 @@
             <a:r>
               <a:rPr lang="en-US" sz="1300" dirty="0">
                 <a:solidFill>
-                  <a:srgbClr val="5E6B60"/>
+                  <a:srgbClr val="55635A"/>
                 </a:solidFill>
                 <a:latin typeface="Calibri" pitchFamily="34" charset="0"/>
                 <a:ea typeface="Calibri" pitchFamily="34" charset="-122"/>
@@ -6851,7 +6936,7 @@
             </a:avLst>
           </a:prstGeom>
           <a:solidFill>
-            <a:srgbClr val="EFF4EE"/>
+            <a:srgbClr val="EDF3ED"/>
           </a:solidFill>
           <a:ln/>
           <a:effectLst>
@@ -6878,7 +6963,7 @@
             <a:avLst/>
           </a:prstGeom>
           <a:solidFill>
-            <a:srgbClr val="B9832B"/>
+            <a:srgbClr val="9C7714"/>
           </a:solidFill>
           <a:ln/>
         </p:spPr>
@@ -6949,7 +7034,7 @@
             <a:r>
               <a:rPr lang="en-US" sz="2100" b="1" dirty="0">
                 <a:solidFill>
-                  <a:srgbClr val="1E4D2B"/>
+                  <a:srgbClr val="15451F"/>
                 </a:solidFill>
                 <a:latin typeface="Cambria" pitchFamily="34" charset="0"/>
                 <a:ea typeface="Cambria" pitchFamily="34" charset="-122"/>
@@ -6991,7 +7076,7 @@
             <a:r>
               <a:rPr lang="en-US" sz="1300" dirty="0">
                 <a:solidFill>
-                  <a:srgbClr val="5E6B60"/>
+                  <a:srgbClr val="55635A"/>
                 </a:solidFill>
                 <a:latin typeface="Calibri" pitchFamily="34" charset="0"/>
                 <a:ea typeface="Calibri" pitchFamily="34" charset="-122"/>
@@ -7020,7 +7105,7 @@
             </a:avLst>
           </a:prstGeom>
           <a:solidFill>
-            <a:srgbClr val="EFF4EE"/>
+            <a:srgbClr val="EDF3ED"/>
           </a:solidFill>
           <a:ln/>
           <a:effectLst>
@@ -7047,7 +7132,7 @@
             <a:avLst/>
           </a:prstGeom>
           <a:solidFill>
-            <a:srgbClr val="6FA86A"/>
+            <a:srgbClr val="4E8C55"/>
           </a:solidFill>
           <a:ln/>
         </p:spPr>
@@ -7118,7 +7203,7 @@
             <a:r>
               <a:rPr lang="en-US" sz="2100" b="1" dirty="0">
                 <a:solidFill>
-                  <a:srgbClr val="1E4D2B"/>
+                  <a:srgbClr val="15451F"/>
                 </a:solidFill>
                 <a:latin typeface="Cambria" pitchFamily="34" charset="0"/>
                 <a:ea typeface="Cambria" pitchFamily="34" charset="-122"/>
@@ -7160,7 +7245,7 @@
             <a:r>
               <a:rPr lang="en-US" sz="1300" dirty="0">
                 <a:solidFill>
-                  <a:srgbClr val="5E6B60"/>
+                  <a:srgbClr val="55635A"/>
                 </a:solidFill>
                 <a:latin typeface="Calibri" pitchFamily="34" charset="0"/>
                 <a:ea typeface="Calibri" pitchFamily="34" charset="-122"/>
@@ -7199,7 +7284,7 @@
             <a:r>
               <a:rPr lang="en-US" sz="900" dirty="0">
                 <a:solidFill>
-                  <a:srgbClr val="5E6B60"/>
+                  <a:srgbClr val="55635A"/>
                 </a:solidFill>
                 <a:latin typeface="Calibri" pitchFamily="34" charset="0"/>
                 <a:ea typeface="Calibri" pitchFamily="34" charset="-122"/>
@@ -7252,7 +7337,7 @@
             <a:r>
               <a:rPr lang="en-US" sz="1000" dirty="0">
                 <a:solidFill>
-                  <a:srgbClr val="5E6B60"/>
+                  <a:srgbClr val="55635A"/>
                 </a:solidFill>
                 <a:latin typeface="Calibri" pitchFamily="34" charset="0"/>
                 <a:ea typeface="Calibri" pitchFamily="34" charset="-122"/>
@@ -7323,7 +7408,7 @@
             <a:r>
               <a:rPr lang="en-US" sz="1300" b="1" spc="200" kern="0" dirty="0">
                 <a:solidFill>
-                  <a:srgbClr val="B9832B"/>
+                  <a:srgbClr val="9C7714"/>
                 </a:solidFill>
                 <a:latin typeface="Calibri" pitchFamily="34" charset="0"/>
                 <a:ea typeface="Calibri" pitchFamily="34" charset="-122"/>
@@ -7362,7 +7447,7 @@
             <a:r>
               <a:rPr lang="en-US" sz="3400" b="1" dirty="0">
                 <a:solidFill>
-                  <a:srgbClr val="1E4D2B"/>
+                  <a:srgbClr val="15451F"/>
                 </a:solidFill>
                 <a:latin typeface="Cambria" pitchFamily="34" charset="0"/>
                 <a:ea typeface="Cambria" pitchFamily="34" charset="-122"/>
@@ -7454,7 +7539,7 @@
             <a:avLst/>
           </a:prstGeom>
           <a:solidFill>
-            <a:srgbClr val="1E4D2B"/>
+            <a:srgbClr val="15451F"/>
           </a:solidFill>
           <a:ln/>
         </p:spPr>
@@ -7525,7 +7610,7 @@
             <a:r>
               <a:rPr lang="en-US" sz="1700" b="1" dirty="0">
                 <a:solidFill>
-                  <a:srgbClr val="1E4D2B"/>
+                  <a:srgbClr val="15451F"/>
                 </a:solidFill>
                 <a:latin typeface="Cambria" pitchFamily="34" charset="0"/>
                 <a:ea typeface="Cambria" pitchFamily="34" charset="-122"/>
@@ -7567,7 +7652,7 @@
             <a:r>
               <a:rPr lang="en-US" sz="1300" dirty="0">
                 <a:solidFill>
-                  <a:srgbClr val="5E6B60"/>
+                  <a:srgbClr val="55635A"/>
                 </a:solidFill>
                 <a:latin typeface="Calibri" pitchFamily="34" charset="0"/>
                 <a:ea typeface="Calibri" pitchFamily="34" charset="-122"/>
@@ -7596,7 +7681,7 @@
             </a:avLst>
           </a:prstGeom>
           <a:solidFill>
-            <a:srgbClr val="EFF4EE"/>
+            <a:srgbClr val="EDF3ED"/>
           </a:solidFill>
           <a:ln/>
           <a:effectLst>
@@ -7623,7 +7708,7 @@
             <a:avLst/>
           </a:prstGeom>
           <a:solidFill>
-            <a:srgbClr val="1E4D2B"/>
+            <a:srgbClr val="15451F"/>
           </a:solidFill>
           <a:ln/>
         </p:spPr>
@@ -7694,7 +7779,7 @@
             <a:r>
               <a:rPr lang="en-US" sz="1700" b="1" dirty="0">
                 <a:solidFill>
-                  <a:srgbClr val="1E4D2B"/>
+                  <a:srgbClr val="15451F"/>
                 </a:solidFill>
                 <a:latin typeface="Cambria" pitchFamily="34" charset="0"/>
                 <a:ea typeface="Cambria" pitchFamily="34" charset="-122"/>
@@ -7736,7 +7821,7 @@
             <a:r>
               <a:rPr lang="en-US" sz="1300" dirty="0">
                 <a:solidFill>
-                  <a:srgbClr val="5E6B60"/>
+                  <a:srgbClr val="55635A"/>
                 </a:solidFill>
                 <a:latin typeface="Calibri" pitchFamily="34" charset="0"/>
                 <a:ea typeface="Calibri" pitchFamily="34" charset="-122"/>
@@ -7792,7 +7877,7 @@
             <a:avLst/>
           </a:prstGeom>
           <a:solidFill>
-            <a:srgbClr val="1E4D2B"/>
+            <a:srgbClr val="15451F"/>
           </a:solidFill>
           <a:ln/>
         </p:spPr>
@@ -7863,7 +7948,7 @@
             <a:r>
               <a:rPr lang="en-US" sz="1700" b="1" dirty="0">
                 <a:solidFill>
-                  <a:srgbClr val="1E4D2B"/>
+                  <a:srgbClr val="15451F"/>
                 </a:solidFill>
                 <a:latin typeface="Cambria" pitchFamily="34" charset="0"/>
                 <a:ea typeface="Cambria" pitchFamily="34" charset="-122"/>
@@ -7905,7 +7990,7 @@
             <a:r>
               <a:rPr lang="en-US" sz="1300" dirty="0">
                 <a:solidFill>
-                  <a:srgbClr val="5E6B60"/>
+                  <a:srgbClr val="55635A"/>
                 </a:solidFill>
                 <a:latin typeface="Calibri" pitchFamily="34" charset="0"/>
                 <a:ea typeface="Calibri" pitchFamily="34" charset="-122"/>
@@ -7934,7 +8019,7 @@
             </a:avLst>
           </a:prstGeom>
           <a:solidFill>
-            <a:srgbClr val="EFF4EE"/>
+            <a:srgbClr val="EDF3ED"/>
           </a:solidFill>
           <a:ln/>
           <a:effectLst>
@@ -7961,7 +8046,7 @@
             <a:avLst/>
           </a:prstGeom>
           <a:solidFill>
-            <a:srgbClr val="1E4D2B"/>
+            <a:srgbClr val="15451F"/>
           </a:solidFill>
           <a:ln/>
         </p:spPr>
@@ -8032,7 +8117,7 @@
             <a:r>
               <a:rPr lang="en-US" sz="1700" b="1" dirty="0">
                 <a:solidFill>
-                  <a:srgbClr val="1E4D2B"/>
+                  <a:srgbClr val="15451F"/>
                 </a:solidFill>
                 <a:latin typeface="Cambria" pitchFamily="34" charset="0"/>
                 <a:ea typeface="Cambria" pitchFamily="34" charset="-122"/>
@@ -8074,7 +8159,7 @@
             <a:r>
               <a:rPr lang="en-US" sz="1300" dirty="0">
                 <a:solidFill>
-                  <a:srgbClr val="5E6B60"/>
+                  <a:srgbClr val="55635A"/>
                 </a:solidFill>
                 <a:latin typeface="Calibri" pitchFamily="34" charset="0"/>
                 <a:ea typeface="Calibri" pitchFamily="34" charset="-122"/>
@@ -8113,7 +8198,7 @@
             <a:r>
               <a:rPr lang="en-US" sz="1300" i="1" dirty="0">
                 <a:solidFill>
-                  <a:srgbClr val="B9832B"/>
+                  <a:srgbClr val="9C7714"/>
                 </a:solidFill>
                 <a:latin typeface="Calibri" pitchFamily="34" charset="0"/>
                 <a:ea typeface="Calibri" pitchFamily="34" charset="-122"/>
@@ -8152,7 +8237,7 @@
             <a:r>
               <a:rPr lang="en-US" sz="900" dirty="0">
                 <a:solidFill>
-                  <a:srgbClr val="5E6B60"/>
+                  <a:srgbClr val="55635A"/>
                 </a:solidFill>
                 <a:latin typeface="Calibri" pitchFamily="34" charset="0"/>
                 <a:ea typeface="Calibri" pitchFamily="34" charset="-122"/>
@@ -8205,7 +8290,7 @@
             <a:r>
               <a:rPr lang="en-US" sz="1000" dirty="0">
                 <a:solidFill>
-                  <a:srgbClr val="5E6B60"/>
+                  <a:srgbClr val="55635A"/>
                 </a:solidFill>
                 <a:latin typeface="Calibri" pitchFamily="34" charset="0"/>
                 <a:ea typeface="Calibri" pitchFamily="34" charset="-122"/>
@@ -8276,7 +8361,7 @@
             <a:r>
               <a:rPr lang="en-US" sz="1300" b="1" spc="200" kern="0" dirty="0">
                 <a:solidFill>
-                  <a:srgbClr val="B9832B"/>
+                  <a:srgbClr val="9C7714"/>
                 </a:solidFill>
                 <a:latin typeface="Calibri" pitchFamily="34" charset="0"/>
                 <a:ea typeface="Calibri" pitchFamily="34" charset="-122"/>
@@ -8315,7 +8400,7 @@
             <a:r>
               <a:rPr lang="en-US" sz="3400" b="1" dirty="0">
                 <a:solidFill>
-                  <a:srgbClr val="1E4D2B"/>
+                  <a:srgbClr val="15451F"/>
                 </a:solidFill>
                 <a:latin typeface="Cambria" pitchFamily="34" charset="0"/>
                 <a:ea typeface="Cambria" pitchFamily="34" charset="-122"/>
@@ -8407,7 +8492,7 @@
             <a:avLst/>
           </a:prstGeom>
           <a:solidFill>
-            <a:srgbClr val="2E7D46"/>
+            <a:srgbClr val="236B30"/>
           </a:solidFill>
           <a:ln/>
         </p:spPr>
@@ -8478,7 +8563,7 @@
             <a:r>
               <a:rPr lang="en-US" sz="1700" b="1" dirty="0">
                 <a:solidFill>
-                  <a:srgbClr val="1E4D2B"/>
+                  <a:srgbClr val="15451F"/>
                 </a:solidFill>
                 <a:latin typeface="Cambria" pitchFamily="34" charset="0"/>
                 <a:ea typeface="Cambria" pitchFamily="34" charset="-122"/>
@@ -8520,7 +8605,7 @@
             <a:r>
               <a:rPr lang="en-US" sz="1300" dirty="0">
                 <a:solidFill>
-                  <a:srgbClr val="5E6B60"/>
+                  <a:srgbClr val="55635A"/>
                 </a:solidFill>
                 <a:latin typeface="Calibri" pitchFamily="34" charset="0"/>
                 <a:ea typeface="Calibri" pitchFamily="34" charset="-122"/>
@@ -8549,7 +8634,7 @@
             </a:avLst>
           </a:prstGeom>
           <a:solidFill>
-            <a:srgbClr val="EFF4EE"/>
+            <a:srgbClr val="EDF3ED"/>
           </a:solidFill>
           <a:ln/>
           <a:effectLst>
@@ -8576,7 +8661,7 @@
             <a:avLst/>
           </a:prstGeom>
           <a:solidFill>
-            <a:srgbClr val="2E7D46"/>
+            <a:srgbClr val="236B30"/>
           </a:solidFill>
           <a:ln/>
         </p:spPr>
@@ -8647,7 +8732,7 @@
             <a:r>
               <a:rPr lang="en-US" sz="1700" b="1" dirty="0">
                 <a:solidFill>
-                  <a:srgbClr val="1E4D2B"/>
+                  <a:srgbClr val="15451F"/>
                 </a:solidFill>
                 <a:latin typeface="Cambria" pitchFamily="34" charset="0"/>
                 <a:ea typeface="Cambria" pitchFamily="34" charset="-122"/>
@@ -8689,7 +8774,7 @@
             <a:r>
               <a:rPr lang="en-US" sz="1300" dirty="0">
                 <a:solidFill>
-                  <a:srgbClr val="5E6B60"/>
+                  <a:srgbClr val="55635A"/>
                 </a:solidFill>
                 <a:latin typeface="Calibri" pitchFamily="34" charset="0"/>
                 <a:ea typeface="Calibri" pitchFamily="34" charset="-122"/>
@@ -8745,7 +8830,7 @@
             <a:avLst/>
           </a:prstGeom>
           <a:solidFill>
-            <a:srgbClr val="2E7D46"/>
+            <a:srgbClr val="236B30"/>
           </a:solidFill>
           <a:ln/>
         </p:spPr>
@@ -8816,7 +8901,7 @@
             <a:r>
               <a:rPr lang="en-US" sz="1700" b="1" dirty="0">
                 <a:solidFill>
-                  <a:srgbClr val="1E4D2B"/>
+                  <a:srgbClr val="15451F"/>
                 </a:solidFill>
                 <a:latin typeface="Cambria" pitchFamily="34" charset="0"/>
                 <a:ea typeface="Cambria" pitchFamily="34" charset="-122"/>
@@ -8858,7 +8943,7 @@
             <a:r>
               <a:rPr lang="en-US" sz="1300" dirty="0">
                 <a:solidFill>
-                  <a:srgbClr val="5E6B60"/>
+                  <a:srgbClr val="55635A"/>
                 </a:solidFill>
                 <a:latin typeface="Calibri" pitchFamily="34" charset="0"/>
                 <a:ea typeface="Calibri" pitchFamily="34" charset="-122"/>
@@ -8887,7 +8972,7 @@
             </a:avLst>
           </a:prstGeom>
           <a:solidFill>
-            <a:srgbClr val="EFF4EE"/>
+            <a:srgbClr val="EDF3ED"/>
           </a:solidFill>
           <a:ln/>
           <a:effectLst>
@@ -8914,7 +8999,7 @@
             <a:avLst/>
           </a:prstGeom>
           <a:solidFill>
-            <a:srgbClr val="2E7D46"/>
+            <a:srgbClr val="236B30"/>
           </a:solidFill>
           <a:ln/>
         </p:spPr>
@@ -8985,7 +9070,7 @@
             <a:r>
               <a:rPr lang="en-US" sz="1700" b="1" dirty="0">
                 <a:solidFill>
-                  <a:srgbClr val="1E4D2B"/>
+                  <a:srgbClr val="15451F"/>
                 </a:solidFill>
                 <a:latin typeface="Cambria" pitchFamily="34" charset="0"/>
                 <a:ea typeface="Cambria" pitchFamily="34" charset="-122"/>
@@ -9027,7 +9112,7 @@
             <a:r>
               <a:rPr lang="en-US" sz="1300" dirty="0">
                 <a:solidFill>
-                  <a:srgbClr val="5E6B60"/>
+                  <a:srgbClr val="55635A"/>
                 </a:solidFill>
                 <a:latin typeface="Calibri" pitchFamily="34" charset="0"/>
                 <a:ea typeface="Calibri" pitchFamily="34" charset="-122"/>
@@ -9066,7 +9151,7 @@
             <a:r>
               <a:rPr lang="en-US" sz="1300" i="1" dirty="0">
                 <a:solidFill>
-                  <a:srgbClr val="B9832B"/>
+                  <a:srgbClr val="9C7714"/>
                 </a:solidFill>
                 <a:latin typeface="Calibri" pitchFamily="34" charset="0"/>
                 <a:ea typeface="Calibri" pitchFamily="34" charset="-122"/>
@@ -9105,7 +9190,7 @@
             <a:r>
               <a:rPr lang="en-US" sz="900" dirty="0">
                 <a:solidFill>
-                  <a:srgbClr val="5E6B60"/>
+                  <a:srgbClr val="55635A"/>
                 </a:solidFill>
                 <a:latin typeface="Calibri" pitchFamily="34" charset="0"/>
                 <a:ea typeface="Calibri" pitchFamily="34" charset="-122"/>
@@ -9158,7 +9243,7 @@
             <a:r>
               <a:rPr lang="en-US" sz="1000" dirty="0">
                 <a:solidFill>
-                  <a:srgbClr val="5E6B60"/>
+                  <a:srgbClr val="55635A"/>
                 </a:solidFill>
                 <a:latin typeface="Calibri" pitchFamily="34" charset="0"/>
                 <a:ea typeface="Calibri" pitchFamily="34" charset="-122"/>
@@ -9229,7 +9314,7 @@
             <a:r>
               <a:rPr lang="en-US" sz="1300" b="1" spc="200" kern="0" dirty="0">
                 <a:solidFill>
-                  <a:srgbClr val="B9832B"/>
+                  <a:srgbClr val="9C7714"/>
                 </a:solidFill>
                 <a:latin typeface="Calibri" pitchFamily="34" charset="0"/>
                 <a:ea typeface="Calibri" pitchFamily="34" charset="-122"/>
@@ -9268,7 +9353,7 @@
             <a:r>
               <a:rPr lang="en-US" sz="3400" b="1" dirty="0">
                 <a:solidFill>
-                  <a:srgbClr val="1E4D2B"/>
+                  <a:srgbClr val="15451F"/>
                 </a:solidFill>
                 <a:latin typeface="Cambria" pitchFamily="34" charset="0"/>
                 <a:ea typeface="Cambria" pitchFamily="34" charset="-122"/>
@@ -9307,7 +9392,7 @@
             <a:r>
               <a:rPr lang="en-US" sz="1450" dirty="0">
                 <a:solidFill>
-                  <a:srgbClr val="5E6B60"/>
+                  <a:srgbClr val="55635A"/>
                 </a:solidFill>
                 <a:latin typeface="Calibri" pitchFamily="34" charset="0"/>
                 <a:ea typeface="Calibri" pitchFamily="34" charset="-122"/>
@@ -9336,7 +9421,7 @@
             </a:avLst>
           </a:prstGeom>
           <a:solidFill>
-            <a:srgbClr val="1E4D2B"/>
+            <a:srgbClr val="15451F"/>
           </a:solidFill>
           <a:ln/>
           <a:effectLst>
@@ -9375,7 +9460,7 @@
             <a:r>
               <a:rPr lang="en-US" sz="2000" b="1" dirty="0">
                 <a:solidFill>
-                  <a:srgbClr val="E0A83B"/>
+                  <a:srgbClr val="D3AF2D"/>
                 </a:solidFill>
                 <a:latin typeface="Courier New" pitchFamily="34" charset="0"/>
                 <a:ea typeface="Courier New" pitchFamily="34" charset="-122"/>
@@ -9428,7 +9513,7 @@
             <a:r>
               <a:rPr lang="en-US" sz="1350" b="1" dirty="0">
                 <a:solidFill>
-                  <a:srgbClr val="1E4D2B"/>
+                  <a:srgbClr val="15451F"/>
                 </a:solidFill>
                 <a:latin typeface="Calibri" pitchFamily="34" charset="0"/>
                 <a:ea typeface="Calibri" pitchFamily="34" charset="-122"/>
@@ -9457,7 +9542,7 @@
             </a:avLst>
           </a:prstGeom>
           <a:solidFill>
-            <a:srgbClr val="FBF3DD"/>
+            <a:srgbClr val="F7EFD6"/>
           </a:solidFill>
           <a:ln/>
           <a:effectLst>
@@ -9525,7 +9610,7 @@
             </a:avLst>
           </a:prstGeom>
           <a:solidFill>
-            <a:srgbClr val="EFF4EE"/>
+            <a:srgbClr val="EDF3ED"/>
           </a:solidFill>
           <a:ln/>
           <a:effectLst>
@@ -9600,7 +9685,7 @@
             <a:r>
               <a:rPr lang="en-US" sz="1400" b="1" dirty="0">
                 <a:solidFill>
-                  <a:srgbClr val="1E4D2B"/>
+                  <a:srgbClr val="15451F"/>
                 </a:solidFill>
                 <a:latin typeface="Cambria" pitchFamily="34" charset="0"/>
                 <a:ea typeface="Cambria" pitchFamily="34" charset="-122"/>
@@ -9642,7 +9727,7 @@
             <a:r>
               <a:rPr lang="en-US" sz="1100" dirty="0">
                 <a:solidFill>
-                  <a:srgbClr val="5E6B60"/>
+                  <a:srgbClr val="55635A"/>
                 </a:solidFill>
                 <a:latin typeface="Calibri" pitchFamily="34" charset="0"/>
                 <a:ea typeface="Calibri" pitchFamily="34" charset="-122"/>
@@ -9671,7 +9756,7 @@
             </a:avLst>
           </a:prstGeom>
           <a:solidFill>
-            <a:srgbClr val="EFF4EE"/>
+            <a:srgbClr val="EDF3ED"/>
           </a:solidFill>
           <a:ln/>
           <a:effectLst>
@@ -9746,7 +9831,7 @@
             <a:r>
               <a:rPr lang="en-US" sz="1400" b="1" dirty="0">
                 <a:solidFill>
-                  <a:srgbClr val="1E4D2B"/>
+                  <a:srgbClr val="15451F"/>
                 </a:solidFill>
                 <a:latin typeface="Cambria" pitchFamily="34" charset="0"/>
                 <a:ea typeface="Cambria" pitchFamily="34" charset="-122"/>
@@ -9788,7 +9873,7 @@
             <a:r>
               <a:rPr lang="en-US" sz="1100" dirty="0">
                 <a:solidFill>
-                  <a:srgbClr val="5E6B60"/>
+                  <a:srgbClr val="55635A"/>
                 </a:solidFill>
                 <a:latin typeface="Calibri" pitchFamily="34" charset="0"/>
                 <a:ea typeface="Calibri" pitchFamily="34" charset="-122"/>
@@ -9817,7 +9902,7 @@
             </a:avLst>
           </a:prstGeom>
           <a:solidFill>
-            <a:srgbClr val="EFF4EE"/>
+            <a:srgbClr val="EDF3ED"/>
           </a:solidFill>
           <a:ln/>
           <a:effectLst>
@@ -9892,7 +9977,7 @@
             <a:r>
               <a:rPr lang="en-US" sz="1400" b="1" dirty="0">
                 <a:solidFill>
-                  <a:srgbClr val="1E4D2B"/>
+                  <a:srgbClr val="15451F"/>
                 </a:solidFill>
                 <a:latin typeface="Cambria" pitchFamily="34" charset="0"/>
                 <a:ea typeface="Cambria" pitchFamily="34" charset="-122"/>
@@ -9934,7 +10019,7 @@
             <a:r>
               <a:rPr lang="en-US" sz="1100" dirty="0">
                 <a:solidFill>
-                  <a:srgbClr val="5E6B60"/>
+                  <a:srgbClr val="55635A"/>
                 </a:solidFill>
                 <a:latin typeface="Calibri" pitchFamily="34" charset="0"/>
                 <a:ea typeface="Calibri" pitchFamily="34" charset="-122"/>
@@ -9973,7 +10058,7 @@
             <a:r>
               <a:rPr lang="en-US" sz="900" dirty="0">
                 <a:solidFill>
-                  <a:srgbClr val="5E6B60"/>
+                  <a:srgbClr val="55635A"/>
                 </a:solidFill>
                 <a:latin typeface="Calibri" pitchFamily="34" charset="0"/>
                 <a:ea typeface="Calibri" pitchFamily="34" charset="-122"/>
@@ -10026,7 +10111,7 @@
             <a:r>
               <a:rPr lang="en-US" sz="1000" dirty="0">
                 <a:solidFill>
-                  <a:srgbClr val="5E6B60"/>
+                  <a:srgbClr val="55635A"/>
                 </a:solidFill>
                 <a:latin typeface="Calibri" pitchFamily="34" charset="0"/>
                 <a:ea typeface="Calibri" pitchFamily="34" charset="-122"/>
@@ -10097,7 +10182,7 @@
             <a:r>
               <a:rPr lang="en-US" sz="1300" b="1" spc="200" kern="0" dirty="0">
                 <a:solidFill>
-                  <a:srgbClr val="B9832B"/>
+                  <a:srgbClr val="9C7714"/>
                 </a:solidFill>
                 <a:latin typeface="Calibri" pitchFamily="34" charset="0"/>
                 <a:ea typeface="Calibri" pitchFamily="34" charset="-122"/>
@@ -10136,7 +10221,7 @@
             <a:r>
               <a:rPr lang="en-US" sz="3400" b="1" dirty="0">
                 <a:solidFill>
-                  <a:srgbClr val="1E4D2B"/>
+                  <a:srgbClr val="15451F"/>
                 </a:solidFill>
                 <a:latin typeface="Cambria" pitchFamily="34" charset="0"/>
                 <a:ea typeface="Cambria" pitchFamily="34" charset="-122"/>
@@ -10165,7 +10250,7 @@
             </a:avLst>
           </a:prstGeom>
           <a:solidFill>
-            <a:srgbClr val="EFF4EE"/>
+            <a:srgbClr val="EDF3ED"/>
           </a:solidFill>
           <a:ln/>
           <a:effectLst>
@@ -10192,7 +10277,7 @@
             <a:avLst/>
           </a:prstGeom>
           <a:solidFill>
-            <a:srgbClr val="6FA86A"/>
+            <a:srgbClr val="4E8C55"/>
           </a:solidFill>
           <a:ln/>
         </p:spPr>
@@ -10263,7 +10348,7 @@
             <a:r>
               <a:rPr lang="en-US" sz="2200" b="1" dirty="0">
                 <a:solidFill>
-                  <a:srgbClr val="1E4D2B"/>
+                  <a:srgbClr val="15451F"/>
                 </a:solidFill>
                 <a:latin typeface="Cambria" pitchFamily="34" charset="0"/>
                 <a:ea typeface="Cambria" pitchFamily="34" charset="-122"/>
@@ -10302,7 +10387,7 @@
             <a:r>
               <a:rPr lang="en-US" sz="1400" dirty="0">
                 <a:solidFill>
-                  <a:srgbClr val="5E6B60"/>
+                  <a:srgbClr val="55635A"/>
                 </a:solidFill>
                 <a:latin typeface="Calibri" pitchFamily="34" charset="0"/>
                 <a:ea typeface="Calibri" pitchFamily="34" charset="-122"/>
@@ -10316,7 +10401,7 @@
             <a:r>
               <a:rPr lang="en-US" sz="1400" b="1" dirty="0">
                 <a:solidFill>
-                  <a:srgbClr val="1E4D2B"/>
+                  <a:srgbClr val="15451F"/>
                 </a:solidFill>
                 <a:latin typeface="Calibri" pitchFamily="34" charset="0"/>
                 <a:ea typeface="Calibri" pitchFamily="34" charset="-122"/>
@@ -10358,7 +10443,7 @@
             <a:r>
               <a:rPr lang="en-US" sz="1400" dirty="0">
                 <a:solidFill>
-                  <a:srgbClr val="5E6B60"/>
+                  <a:srgbClr val="55635A"/>
                 </a:solidFill>
                 <a:latin typeface="Calibri" pitchFamily="34" charset="0"/>
                 <a:ea typeface="Calibri" pitchFamily="34" charset="-122"/>
@@ -10387,7 +10472,7 @@
             <a:r>
               <a:rPr lang="en-US" sz="1400" dirty="0">
                 <a:solidFill>
-                  <a:srgbClr val="5E6B60"/>
+                  <a:srgbClr val="55635A"/>
                 </a:solidFill>
                 <a:latin typeface="Calibri" pitchFamily="34" charset="0"/>
                 <a:ea typeface="Calibri" pitchFamily="34" charset="-122"/>
@@ -10407,7 +10492,7 @@
             <a:r>
               <a:rPr lang="en-US" sz="1400" dirty="0">
                 <a:solidFill>
-                  <a:srgbClr val="5E6B60"/>
+                  <a:srgbClr val="55635A"/>
                 </a:solidFill>
                 <a:latin typeface="Calibri" pitchFamily="34" charset="0"/>
                 <a:ea typeface="Calibri" pitchFamily="34" charset="-122"/>
@@ -10427,7 +10512,7 @@
             <a:r>
               <a:rPr lang="en-US" sz="1400" dirty="0">
                 <a:solidFill>
-                  <a:srgbClr val="5E6B60"/>
+                  <a:srgbClr val="55635A"/>
                 </a:solidFill>
                 <a:latin typeface="Calibri" pitchFamily="34" charset="0"/>
                 <a:ea typeface="Calibri" pitchFamily="34" charset="-122"/>
@@ -10456,7 +10541,7 @@
             </a:avLst>
           </a:prstGeom>
           <a:solidFill>
-            <a:srgbClr val="FBF3DD"/>
+            <a:srgbClr val="F7EFD6"/>
           </a:solidFill>
           <a:ln/>
           <a:effectLst>
@@ -10483,7 +10568,7 @@
             <a:avLst/>
           </a:prstGeom>
           <a:solidFill>
-            <a:srgbClr val="B9832B"/>
+            <a:srgbClr val="9C7714"/>
           </a:solidFill>
           <a:ln/>
         </p:spPr>
@@ -10554,7 +10639,7 @@
             <a:r>
               <a:rPr lang="en-US" sz="2200" b="1" dirty="0">
                 <a:solidFill>
-                  <a:srgbClr val="1E4D2B"/>
+                  <a:srgbClr val="15451F"/>
                 </a:solidFill>
                 <a:latin typeface="Cambria" pitchFamily="34" charset="0"/>
                 <a:ea typeface="Cambria" pitchFamily="34" charset="-122"/>
@@ -10593,7 +10678,7 @@
             <a:r>
               <a:rPr lang="en-US" sz="1400" dirty="0">
                 <a:solidFill>
-                  <a:srgbClr val="5E6B60"/>
+                  <a:srgbClr val="55635A"/>
                 </a:solidFill>
                 <a:latin typeface="Calibri" pitchFamily="34" charset="0"/>
                 <a:ea typeface="Calibri" pitchFamily="34" charset="-122"/>
@@ -10768,7 +10853,7 @@
             <a:r>
               <a:rPr lang="en-US" sz="1250" i="1" dirty="0">
                 <a:solidFill>
-                  <a:srgbClr val="B9832B"/>
+                  <a:srgbClr val="9C7714"/>
                 </a:solidFill>
                 <a:latin typeface="Calibri" pitchFamily="34" charset="0"/>
                 <a:ea typeface="Calibri" pitchFamily="34" charset="-122"/>
@@ -10807,7 +10892,7 @@
             <a:r>
               <a:rPr lang="en-US" sz="900" dirty="0">
                 <a:solidFill>
-                  <a:srgbClr val="5E6B60"/>
+                  <a:srgbClr val="55635A"/>
                 </a:solidFill>
                 <a:latin typeface="Calibri" pitchFamily="34" charset="0"/>
                 <a:ea typeface="Calibri" pitchFamily="34" charset="-122"/>
@@ -10860,7 +10945,7 @@
             <a:r>
               <a:rPr lang="en-US" sz="1000" dirty="0">
                 <a:solidFill>
-                  <a:srgbClr val="5E6B60"/>
+                  <a:srgbClr val="55635A"/>
                 </a:solidFill>
                 <a:latin typeface="Calibri" pitchFamily="34" charset="0"/>
                 <a:ea typeface="Calibri" pitchFamily="34" charset="-122"/>
@@ -10931,7 +11016,7 @@
             <a:r>
               <a:rPr lang="en-US" sz="1300" b="1" spc="200" kern="0" dirty="0">
                 <a:solidFill>
-                  <a:srgbClr val="B9832B"/>
+                  <a:srgbClr val="9C7714"/>
                 </a:solidFill>
                 <a:latin typeface="Calibri" pitchFamily="34" charset="0"/>
                 <a:ea typeface="Calibri" pitchFamily="34" charset="-122"/>
@@ -10970,7 +11055,7 @@
             <a:r>
               <a:rPr lang="en-US" sz="3400" b="1" dirty="0">
                 <a:solidFill>
-                  <a:srgbClr val="1E4D2B"/>
+                  <a:srgbClr val="15451F"/>
                 </a:solidFill>
                 <a:latin typeface="Cambria" pitchFamily="34" charset="0"/>
                 <a:ea typeface="Cambria" pitchFamily="34" charset="-122"/>
@@ -11038,7 +11123,7 @@
             <a:r>
               <a:rPr lang="en-US" sz="2000" dirty="0">
                 <a:solidFill>
-                  <a:srgbClr val="2E7D46"/>
+                  <a:srgbClr val="236B30"/>
                 </a:solidFill>
                 <a:latin typeface="Cambria" pitchFamily="34" charset="0"/>
                 <a:ea typeface="Cambria" pitchFamily="34" charset="-122"/>
@@ -11052,7 +11137,7 @@
             <a:r>
               <a:rPr lang="en-US" sz="2000" b="1" dirty="0">
                 <a:solidFill>
-                  <a:srgbClr val="2E7D46"/>
+                  <a:srgbClr val="236B30"/>
                 </a:solidFill>
                 <a:latin typeface="Cambria" pitchFamily="34" charset="0"/>
                 <a:ea typeface="Cambria" pitchFamily="34" charset="-122"/>
@@ -11094,7 +11179,7 @@
             <a:r>
               <a:rPr lang="en-US" sz="1450" b="1" dirty="0">
                 <a:solidFill>
-                  <a:srgbClr val="2E7D46"/>
+                  <a:srgbClr val="236B30"/>
                 </a:solidFill>
                 <a:latin typeface="Calibri" pitchFamily="34" charset="0"/>
                 <a:ea typeface="Calibri" pitchFamily="34" charset="-122"/>
@@ -11153,7 +11238,7 @@
             <a:r>
               <a:rPr lang="en-US" sz="1450" b="1" dirty="0">
                 <a:solidFill>
-                  <a:srgbClr val="2E7D46"/>
+                  <a:srgbClr val="236B30"/>
                 </a:solidFill>
                 <a:latin typeface="Calibri" pitchFamily="34" charset="0"/>
                 <a:ea typeface="Calibri" pitchFamily="34" charset="-122"/>
@@ -11212,7 +11297,7 @@
             <a:r>
               <a:rPr lang="en-US" sz="1450" b="1" dirty="0">
                 <a:solidFill>
-                  <a:srgbClr val="2E7D46"/>
+                  <a:srgbClr val="236B30"/>
                 </a:solidFill>
                 <a:latin typeface="Calibri" pitchFamily="34" charset="0"/>
                 <a:ea typeface="Calibri" pitchFamily="34" charset="-122"/>
@@ -11271,7 +11356,7 @@
             <a:r>
               <a:rPr lang="en-US" sz="1450" b="1" dirty="0">
                 <a:solidFill>
-                  <a:srgbClr val="2E7D46"/>
+                  <a:srgbClr val="236B30"/>
                 </a:solidFill>
                 <a:latin typeface="Calibri" pitchFamily="34" charset="0"/>
                 <a:ea typeface="Calibri" pitchFamily="34" charset="-122"/>
@@ -11645,7 +11730,7 @@
             <a:r>
               <a:rPr lang="en-US" sz="1250" i="1" dirty="0">
                 <a:solidFill>
-                  <a:srgbClr val="B9832B"/>
+                  <a:srgbClr val="9C7714"/>
                 </a:solidFill>
                 <a:latin typeface="Calibri" pitchFamily="34" charset="0"/>
                 <a:ea typeface="Calibri" pitchFamily="34" charset="-122"/>
@@ -11684,7 +11769,7 @@
             <a:r>
               <a:rPr lang="en-US" sz="900" dirty="0">
                 <a:solidFill>
-                  <a:srgbClr val="5E6B60"/>
+                  <a:srgbClr val="55635A"/>
                 </a:solidFill>
                 <a:latin typeface="Calibri" pitchFamily="34" charset="0"/>
                 <a:ea typeface="Calibri" pitchFamily="34" charset="-122"/>
@@ -11737,7 +11822,7 @@
             <a:r>
               <a:rPr lang="en-US" sz="1000" dirty="0">
                 <a:solidFill>
-                  <a:srgbClr val="5E6B60"/>
+                  <a:srgbClr val="55635A"/>
                 </a:solidFill>
                 <a:latin typeface="Calibri" pitchFamily="34" charset="0"/>
                 <a:ea typeface="Calibri" pitchFamily="34" charset="-122"/>

</xml_diff>